<commit_message>
feat: update flowchart PPTX with billing COPSOQ step
Added step 10 "Verificar Billing" (orange) between "Cadastrar Pessoas"
and "Enviar COPSOQ". Shows the new hybrid billing model where exceedent
COPSOQ invites are paid via PIX/Card/Credits before sending.

Co-Authored-By: Claude Opus 4.6 (1M context) <noreply@anthropic.com>
</commit_message>
<xml_diff>
--- a/docs/Fluxograma_SamurAI_BlackBelt.pptx
+++ b/docs/Fluxograma_SamurAI_BlackBelt.pptx
@@ -3084,7 +3084,7 @@
     <p:bg>
       <p:bgPr>
         <a:solidFill>
-          <a:srgbClr val="F8FAFC"/>
+          <a:srgbClr val="1A1A2E"/>
         </a:solidFill>
         <a:effectLst/>
       </p:bgPr>
@@ -3098,20 +3098,90 @@
       <p:grpSpPr/>
       <p:sp>
         <p:nvSpPr>
-          <p:cNvPr id="2" name="Rounded Rectangle 1"/>
+          <p:cNvPr id="2" name="TextBox 1"/>
+          <p:cNvSpPr txBox="1"/>
+          <p:nvPr/>
+        </p:nvSpPr>
+        <p:spPr>
+          <a:xfrm>
+            <a:off x="457200" y="137160"/>
+            <a:ext cx="7315200" cy="457200"/>
+          </a:xfrm>
+          <a:prstGeom prst="rect">
+            <a:avLst/>
+          </a:prstGeom>
+          <a:noFill/>
+        </p:spPr>
+        <p:txBody>
+          <a:bodyPr wrap="none">
+            <a:spAutoFit/>
+          </a:bodyPr>
+          <a:lstStyle/>
+          <a:p>
+            <a:pPr>
+              <a:defRPr sz="2400" b="1">
+                <a:solidFill>
+                  <a:srgbClr val="C8A55A"/>
+                </a:solidFill>
+              </a:defRPr>
+            </a:pPr>
+            <a:r>
+              <a:t>SamurAI — Fluxo Completo NR-01</a:t>
+            </a:r>
+          </a:p>
+        </p:txBody>
+      </p:sp>
+      <p:sp>
+        <p:nvSpPr>
+          <p:cNvPr id="3" name="TextBox 2"/>
+          <p:cNvSpPr txBox="1"/>
+          <p:nvPr/>
+        </p:nvSpPr>
+        <p:spPr>
+          <a:xfrm>
+            <a:off x="457200" y="502920"/>
+            <a:ext cx="7315200" cy="274320"/>
+          </a:xfrm>
+          <a:prstGeom prst="rect">
+            <a:avLst/>
+          </a:prstGeom>
+          <a:noFill/>
+        </p:spPr>
+        <p:txBody>
+          <a:bodyPr wrap="none">
+            <a:spAutoFit/>
+          </a:bodyPr>
+          <a:lstStyle/>
+          <a:p>
+            <a:pPr>
+              <a:defRPr sz="1100">
+                <a:solidFill>
+                  <a:srgbClr val="999999"/>
+                </a:solidFill>
+              </a:defRPr>
+            </a:pPr>
+            <a:r>
+              <a:t>Black Belt Consultoria | Modelo Hibrido: Mensalidade + Convites COPSOQ</a:t>
+            </a:r>
+          </a:p>
+        </p:txBody>
+      </p:sp>
+      <p:sp>
+        <p:nvSpPr>
+          <p:cNvPr id="4" name="Rounded Rectangle 3"/>
           <p:cNvSpPr/>
           <p:nvPr/>
         </p:nvSpPr>
         <p:spPr>
           <a:xfrm>
-            <a:off x="274320" y="274320"/>
-            <a:ext cx="11640312" cy="1097280"/>
+            <a:off x="274320" y="914400"/>
+            <a:ext cx="1691640" cy="1280160"/>
           </a:xfrm>
           <a:prstGeom prst="roundRect">
             <a:avLst/>
           </a:prstGeom>
           <a:solidFill>
-            <a:srgbClr val="1E40AF"/>
+            <a:srgbClr val="C8A55A"/>
           </a:solidFill>
           <a:ln>
             <a:noFill/>
@@ -3135,110 +3205,71 @@
           <a:bodyPr rtlCol="0" anchor="ctr" wrap="square"/>
           <a:lstStyle/>
           <a:p>
-            <a:pPr algn="ctr"/>
-            <a:r>
-              <a:rPr sz="3200" b="1">
-                <a:solidFill>
-                  <a:srgbClr val="FFFFFF"/>
-                </a:solidFill>
-              </a:rPr>
-              <a:t>SamurAI - Fluxo Completo NR-01</a:t>
-            </a:r>
-          </a:p>
-          <a:p>
-            <a:pPr algn="ctr"/>
-            <a:r>
-              <a:rPr sz="1600">
-                <a:solidFill>
-                  <a:srgbClr val="BED0FE"/>
-                </a:solidFill>
-              </a:rPr>
-              <a:t>Black Belt Consultoria | Gestao de Riscos Psicossociais</a:t>
-            </a:r>
-          </a:p>
-        </p:txBody>
-      </p:sp>
-      <p:sp>
-        <p:nvSpPr>
-          <p:cNvPr id="3" name="Rounded Rectangle 2"/>
+            <a:pPr algn="l">
+              <a:defRPr sz="1000" b="1">
+                <a:solidFill>
+                  <a:srgbClr val="FFFFFF"/>
+                </a:solidFill>
+              </a:defRPr>
+            </a:pPr>
+            <a:r>
+              <a:t>1</a:t>
+            </a:r>
+          </a:p>
+          <a:p>
+            <a:pPr algn="ctr">
+              <a:defRPr sz="1100" b="1">
+                <a:solidFill>
+                  <a:srgbClr val="FFFFFF"/>
+                </a:solidFill>
+              </a:defRPr>
+            </a:pPr>
+            <a:r>
+              <a:t>Inserir CNPJ</a:t>
+            </a:r>
+          </a:p>
+          <a:p>
+            <a:pPr algn="ctr">
+              <a:defRPr sz="800">
+                <a:solidFill>
+                  <a:srgbClr val="FFFFFF"/>
+                </a:solidFill>
+              </a:defRPr>
+            </a:pPr>
+            <a:r>
+              <a:t>CNPJ + funcionarios</a:t>
+            </a:r>
+          </a:p>
+          <a:p>
+            <a:pPr algn="ctr">
+              <a:defRPr sz="800">
+                <a:solidFill>
+                  <a:srgbClr val="FFFFFF"/>
+                </a:solidFill>
+              </a:defRPr>
+            </a:pPr>
+            <a:r>
+              <a:t>+ email</a:t>
+            </a:r>
+          </a:p>
+        </p:txBody>
+      </p:sp>
+      <p:sp>
+        <p:nvSpPr>
+          <p:cNvPr id="5" name="Rounded Rectangle 4"/>
           <p:cNvSpPr/>
           <p:nvPr/>
         </p:nvSpPr>
         <p:spPr>
           <a:xfrm>
-            <a:off x="274320" y="1645920"/>
-            <a:ext cx="2011680" cy="777240"/>
+            <a:off x="2148840" y="914400"/>
+            <a:ext cx="1691640" cy="1280160"/>
           </a:xfrm>
           <a:prstGeom prst="roundRect">
             <a:avLst/>
           </a:prstGeom>
           <a:solidFill>
-            <a:srgbClr val="DBEAFE"/>
-          </a:solidFill>
-          <a:ln w="25400">
-            <a:solidFill>
-              <a:srgbClr val="1E40AF"/>
-            </a:solidFill>
-          </a:ln>
-        </p:spPr>
-        <p:style>
-          <a:lnRef idx="1">
-            <a:schemeClr val="accent1"/>
-          </a:lnRef>
-          <a:fillRef idx="3">
-            <a:schemeClr val="accent1"/>
-          </a:fillRef>
-          <a:effectRef idx="2">
-            <a:schemeClr val="accent1"/>
-          </a:effectRef>
-          <a:fontRef idx="minor">
-            <a:schemeClr val="lt1"/>
-          </a:fontRef>
-        </p:style>
-        <p:txBody>
-          <a:bodyPr rtlCol="0" anchor="ctr" wrap="square"/>
-          <a:lstStyle/>
-          <a:p>
-            <a:pPr algn="l"/>
-            <a:r>
-              <a:rPr sz="1000" b="1">
-                <a:solidFill>
-                  <a:srgbClr val="1F2937"/>
-                </a:solidFill>
-              </a:rPr>
-              <a:t>1. Inserir CNPJ</a:t>
-            </a:r>
-          </a:p>
-          <a:p>
-            <a:pPr algn="l"/>
-            <a:r>
-              <a:rPr sz="700">
-                <a:solidFill>
-                  <a:srgbClr val="6B7280"/>
-                </a:solidFill>
-              </a:rPr>
-              <a:t>Consultor digita CNPJ
-+ funcionarios + email</a:t>
-            </a:r>
-          </a:p>
-        </p:txBody>
-      </p:sp>
-      <p:sp>
-        <p:nvSpPr>
-          <p:cNvPr id="4" name="Right Arrow 3"/>
-          <p:cNvSpPr/>
-          <p:nvPr/>
-        </p:nvSpPr>
-        <p:spPr>
-          <a:xfrm>
-            <a:off x="2286000" y="1943100"/>
-            <a:ext cx="228600" cy="182880"/>
-          </a:xfrm>
-          <a:prstGeom prst="rightArrow">
-            <a:avLst/>
-          </a:prstGeom>
-          <a:solidFill>
-            <a:srgbClr val="6B7280"/>
+            <a:srgbClr val="C8A55A"/>
           </a:solidFill>
           <a:ln>
             <a:noFill/>
@@ -3259,94 +3290,74 @@
           </a:fontRef>
         </p:style>
         <p:txBody>
-          <a:bodyPr rtlCol="0" anchor="ctr"/>
-          <a:lstStyle/>
-          <a:p>
-            <a:pPr algn="ctr"/>
-          </a:p>
-        </p:txBody>
-      </p:sp>
-      <p:sp>
-        <p:nvSpPr>
-          <p:cNvPr id="5" name="Rounded Rectangle 4"/>
+          <a:bodyPr rtlCol="0" anchor="ctr" wrap="square"/>
+          <a:lstStyle/>
+          <a:p>
+            <a:pPr algn="l">
+              <a:defRPr sz="1000" b="1">
+                <a:solidFill>
+                  <a:srgbClr val="FFFFFF"/>
+                </a:solidFill>
+              </a:defRPr>
+            </a:pPr>
+            <a:r>
+              <a:t>2</a:t>
+            </a:r>
+          </a:p>
+          <a:p>
+            <a:pPr algn="ctr">
+              <a:defRPr sz="1100" b="1">
+                <a:solidFill>
+                  <a:srgbClr val="FFFFFF"/>
+                </a:solidFill>
+              </a:defRPr>
+            </a:pPr>
+            <a:r>
+              <a:t>Consulta Receita</a:t>
+            </a:r>
+          </a:p>
+          <a:p>
+            <a:pPr algn="ctr">
+              <a:defRPr sz="800">
+                <a:solidFill>
+                  <a:srgbClr val="FFFFFF"/>
+                </a:solidFill>
+              </a:defRPr>
+            </a:pPr>
+            <a:r>
+              <a:t>Busca automatica</a:t>
+            </a:r>
+          </a:p>
+          <a:p>
+            <a:pPr algn="ctr">
+              <a:defRPr sz="800">
+                <a:solidFill>
+                  <a:srgbClr val="FFFFFF"/>
+                </a:solidFill>
+              </a:defRPr>
+            </a:pPr>
+            <a:r>
+              <a:t>Receita Federal</a:t>
+            </a:r>
+          </a:p>
+        </p:txBody>
+      </p:sp>
+      <p:sp>
+        <p:nvSpPr>
+          <p:cNvPr id="6" name="Rounded Rectangle 5"/>
           <p:cNvSpPr/>
           <p:nvPr/>
         </p:nvSpPr>
         <p:spPr>
           <a:xfrm>
-            <a:off x="2514600" y="1645920"/>
-            <a:ext cx="2011680" cy="777240"/>
+            <a:off x="4023360" y="914400"/>
+            <a:ext cx="1691640" cy="1280160"/>
           </a:xfrm>
           <a:prstGeom prst="roundRect">
             <a:avLst/>
           </a:prstGeom>
           <a:solidFill>
-            <a:srgbClr val="DBEAFE"/>
-          </a:solidFill>
-          <a:ln w="25400">
-            <a:solidFill>
-              <a:srgbClr val="1E40AF"/>
-            </a:solidFill>
-          </a:ln>
-        </p:spPr>
-        <p:style>
-          <a:lnRef idx="1">
-            <a:schemeClr val="accent1"/>
-          </a:lnRef>
-          <a:fillRef idx="3">
-            <a:schemeClr val="accent1"/>
-          </a:fillRef>
-          <a:effectRef idx="2">
-            <a:schemeClr val="accent1"/>
-          </a:effectRef>
-          <a:fontRef idx="minor">
-            <a:schemeClr val="lt1"/>
-          </a:fontRef>
-        </p:style>
-        <p:txBody>
-          <a:bodyPr rtlCol="0" anchor="ctr" wrap="square"/>
-          <a:lstStyle/>
-          <a:p>
-            <a:pPr algn="l"/>
-            <a:r>
-              <a:rPr sz="1000" b="1">
-                <a:solidFill>
-                  <a:srgbClr val="1F2937"/>
-                </a:solidFill>
-              </a:rPr>
-              <a:t>2. Consulta Receita</a:t>
-            </a:r>
-          </a:p>
-          <a:p>
-            <a:pPr algn="l"/>
-            <a:r>
-              <a:rPr sz="700">
-                <a:solidFill>
-                  <a:srgbClr val="6B7280"/>
-                </a:solidFill>
-              </a:rPr>
-              <a:t>Busca automatica
-na Receita Federal</a:t>
-            </a:r>
-          </a:p>
-        </p:txBody>
-      </p:sp>
-      <p:sp>
-        <p:nvSpPr>
-          <p:cNvPr id="6" name="Right Arrow 5"/>
-          <p:cNvSpPr/>
-          <p:nvPr/>
-        </p:nvSpPr>
-        <p:spPr>
-          <a:xfrm>
-            <a:off x="4526280" y="1943100"/>
-            <a:ext cx="228600" cy="182880"/>
-          </a:xfrm>
-          <a:prstGeom prst="rightArrow">
-            <a:avLst/>
-          </a:prstGeom>
-          <a:solidFill>
-            <a:srgbClr val="6B7280"/>
+            <a:srgbClr val="C8A55A"/>
           </a:solidFill>
           <a:ln>
             <a:noFill/>
@@ -3367,10 +3378,55 @@
           </a:fontRef>
         </p:style>
         <p:txBody>
-          <a:bodyPr rtlCol="0" anchor="ctr"/>
-          <a:lstStyle/>
-          <a:p>
-            <a:pPr algn="ctr"/>
+          <a:bodyPr rtlCol="0" anchor="ctr" wrap="square"/>
+          <a:lstStyle/>
+          <a:p>
+            <a:pPr algn="l">
+              <a:defRPr sz="1000" b="1">
+                <a:solidFill>
+                  <a:srgbClr val="FFFFFF"/>
+                </a:solidFill>
+              </a:defRPr>
+            </a:pPr>
+            <a:r>
+              <a:t>3</a:t>
+            </a:r>
+          </a:p>
+          <a:p>
+            <a:pPr algn="ctr">
+              <a:defRPr sz="1100" b="1">
+                <a:solidFill>
+                  <a:srgbClr val="FFFFFF"/>
+                </a:solidFill>
+              </a:defRPr>
+            </a:pPr>
+            <a:r>
+              <a:t>Cadastro Empresa</a:t>
+            </a:r>
+          </a:p>
+          <a:p>
+            <a:pPr algn="ctr">
+              <a:defRPr sz="800">
+                <a:solidFill>
+                  <a:srgbClr val="FFFFFF"/>
+                </a:solidFill>
+              </a:defRPr>
+            </a:pPr>
+            <a:r>
+              <a:t>Cria tenant + checklist</a:t>
+            </a:r>
+          </a:p>
+          <a:p>
+            <a:pPr algn="ctr">
+              <a:defRPr sz="800">
+                <a:solidFill>
+                  <a:srgbClr val="FFFFFF"/>
+                </a:solidFill>
+              </a:defRPr>
+            </a:pPr>
+            <a:r>
+              <a:t>NR-01 automatico</a:t>
+            </a:r>
           </a:p>
         </p:txBody>
       </p:sp>
@@ -3382,79 +3438,14 @@
         </p:nvSpPr>
         <p:spPr>
           <a:xfrm>
-            <a:off x="4754880" y="1645920"/>
-            <a:ext cx="2011680" cy="777240"/>
+            <a:off x="5897880" y="914400"/>
+            <a:ext cx="1691640" cy="1280160"/>
           </a:xfrm>
           <a:prstGeom prst="roundRect">
             <a:avLst/>
           </a:prstGeom>
           <a:solidFill>
-            <a:srgbClr val="DCFCE7"/>
-          </a:solidFill>
-          <a:ln w="25400">
-            <a:solidFill>
-              <a:srgbClr val="16A34A"/>
-            </a:solidFill>
-          </a:ln>
-        </p:spPr>
-        <p:style>
-          <a:lnRef idx="1">
-            <a:schemeClr val="accent1"/>
-          </a:lnRef>
-          <a:fillRef idx="3">
-            <a:schemeClr val="accent1"/>
-          </a:fillRef>
-          <a:effectRef idx="2">
-            <a:schemeClr val="accent1"/>
-          </a:effectRef>
-          <a:fontRef idx="minor">
-            <a:schemeClr val="lt1"/>
-          </a:fontRef>
-        </p:style>
-        <p:txBody>
-          <a:bodyPr rtlCol="0" anchor="ctr" wrap="square"/>
-          <a:lstStyle/>
-          <a:p>
-            <a:pPr algn="l"/>
-            <a:r>
-              <a:rPr sz="1000" b="1">
-                <a:solidFill>
-                  <a:srgbClr val="1F2937"/>
-                </a:solidFill>
-              </a:rPr>
-              <a:t>3. Cadastro Empresa</a:t>
-            </a:r>
-          </a:p>
-          <a:p>
-            <a:pPr algn="l"/>
-            <a:r>
-              <a:rPr sz="700">
-                <a:solidFill>
-                  <a:srgbClr val="6B7280"/>
-                </a:solidFill>
-              </a:rPr>
-              <a:t>Cria tenant + checklist
-NR-01 automatico</a:t>
-            </a:r>
-          </a:p>
-        </p:txBody>
-      </p:sp>
-      <p:sp>
-        <p:nvSpPr>
-          <p:cNvPr id="8" name="Right Arrow 7"/>
-          <p:cNvSpPr/>
-          <p:nvPr/>
-        </p:nvSpPr>
-        <p:spPr>
-          <a:xfrm>
-            <a:off x="6766560" y="1943100"/>
-            <a:ext cx="228600" cy="182880"/>
-          </a:xfrm>
-          <a:prstGeom prst="rightArrow">
-            <a:avLst/>
-          </a:prstGeom>
-          <a:solidFill>
-            <a:srgbClr val="6B7280"/>
+            <a:srgbClr val="4A90D9"/>
           </a:solidFill>
           <a:ln>
             <a:noFill/>
@@ -3475,94 +3466,74 @@
           </a:fontRef>
         </p:style>
         <p:txBody>
-          <a:bodyPr rtlCol="0" anchor="ctr"/>
-          <a:lstStyle/>
-          <a:p>
-            <a:pPr algn="ctr"/>
-          </a:p>
-        </p:txBody>
-      </p:sp>
-      <p:sp>
-        <p:nvSpPr>
-          <p:cNvPr id="9" name="Rounded Rectangle 8"/>
+          <a:bodyPr rtlCol="0" anchor="ctr" wrap="square"/>
+          <a:lstStyle/>
+          <a:p>
+            <a:pPr algn="l">
+              <a:defRPr sz="1000" b="1">
+                <a:solidFill>
+                  <a:srgbClr val="FFFFFF"/>
+                </a:solidFill>
+              </a:defRPr>
+            </a:pPr>
+            <a:r>
+              <a:t>4</a:t>
+            </a:r>
+          </a:p>
+          <a:p>
+            <a:pPr algn="ctr">
+              <a:defRPr sz="1100" b="1">
+                <a:solidFill>
+                  <a:srgbClr val="FFFFFF"/>
+                </a:solidFill>
+              </a:defRPr>
+            </a:pPr>
+            <a:r>
+              <a:t>Pre-Proposta</a:t>
+            </a:r>
+          </a:p>
+          <a:p>
+            <a:pPr algn="ctr">
+              <a:defRPr sz="800">
+                <a:solidFill>
+                  <a:srgbClr val="FFFFFF"/>
+                </a:solidFill>
+              </a:defRPr>
+            </a:pPr>
+            <a:r>
+              <a:t>Gera estimativa</a:t>
+            </a:r>
+          </a:p>
+          <a:p>
+            <a:pPr algn="ctr">
+              <a:defRPr sz="800">
+                <a:solidFill>
+                  <a:srgbClr val="FFFFFF"/>
+                </a:solidFill>
+              </a:defRPr>
+            </a:pPr>
+            <a:r>
+              <a:t>porte/setor</a:t>
+            </a:r>
+          </a:p>
+        </p:txBody>
+      </p:sp>
+      <p:sp>
+        <p:nvSpPr>
+          <p:cNvPr id="8" name="Rounded Rectangle 7"/>
           <p:cNvSpPr/>
           <p:nvPr/>
         </p:nvSpPr>
         <p:spPr>
           <a:xfrm>
-            <a:off x="6995160" y="1645920"/>
-            <a:ext cx="2011680" cy="777240"/>
+            <a:off x="7772400" y="914400"/>
+            <a:ext cx="1691640" cy="1280160"/>
           </a:xfrm>
           <a:prstGeom prst="roundRect">
             <a:avLst/>
           </a:prstGeom>
           <a:solidFill>
-            <a:srgbClr val="FFF7ED"/>
-          </a:solidFill>
-          <a:ln w="25400">
-            <a:solidFill>
-              <a:srgbClr val="EA580C"/>
-            </a:solidFill>
-          </a:ln>
-        </p:spPr>
-        <p:style>
-          <a:lnRef idx="1">
-            <a:schemeClr val="accent1"/>
-          </a:lnRef>
-          <a:fillRef idx="3">
-            <a:schemeClr val="accent1"/>
-          </a:fillRef>
-          <a:effectRef idx="2">
-            <a:schemeClr val="accent1"/>
-          </a:effectRef>
-          <a:fontRef idx="minor">
-            <a:schemeClr val="lt1"/>
-          </a:fontRef>
-        </p:style>
-        <p:txBody>
-          <a:bodyPr rtlCol="0" anchor="ctr" wrap="square"/>
-          <a:lstStyle/>
-          <a:p>
-            <a:pPr algn="l"/>
-            <a:r>
-              <a:rPr sz="1000" b="1">
-                <a:solidFill>
-                  <a:srgbClr val="1F2937"/>
-                </a:solidFill>
-              </a:rPr>
-              <a:t>4. Pre-Proposta</a:t>
-            </a:r>
-          </a:p>
-          <a:p>
-            <a:pPr algn="l"/>
-            <a:r>
-              <a:rPr sz="700">
-                <a:solidFill>
-                  <a:srgbClr val="6B7280"/>
-                </a:solidFill>
-              </a:rPr>
-              <a:t>Gera estimativa com
-base no porte/setor</a:t>
-            </a:r>
-          </a:p>
-        </p:txBody>
-      </p:sp>
-      <p:sp>
-        <p:nvSpPr>
-          <p:cNvPr id="10" name="Right Arrow 9"/>
-          <p:cNvSpPr/>
-          <p:nvPr/>
-        </p:nvSpPr>
-        <p:spPr>
-          <a:xfrm>
-            <a:off x="9006840" y="1943100"/>
-            <a:ext cx="228600" cy="182880"/>
-          </a:xfrm>
-          <a:prstGeom prst="rightArrow">
-            <a:avLst/>
-          </a:prstGeom>
-          <a:solidFill>
-            <a:srgbClr val="6B7280"/>
+            <a:srgbClr val="4A90D9"/>
           </a:solidFill>
           <a:ln>
             <a:noFill/>
@@ -3583,94 +3554,74 @@
           </a:fontRef>
         </p:style>
         <p:txBody>
-          <a:bodyPr rtlCol="0" anchor="ctr"/>
-          <a:lstStyle/>
-          <a:p>
-            <a:pPr algn="ctr"/>
-          </a:p>
-        </p:txBody>
-      </p:sp>
-      <p:sp>
-        <p:nvSpPr>
-          <p:cNvPr id="11" name="Rounded Rectangle 10"/>
+          <a:bodyPr rtlCol="0" anchor="ctr" wrap="square"/>
+          <a:lstStyle/>
+          <a:p>
+            <a:pPr algn="l">
+              <a:defRPr sz="1000" b="1">
+                <a:solidFill>
+                  <a:srgbClr val="FFFFFF"/>
+                </a:solidFill>
+              </a:defRPr>
+            </a:pPr>
+            <a:r>
+              <a:t>5</a:t>
+            </a:r>
+          </a:p>
+          <a:p>
+            <a:pPr algn="ctr">
+              <a:defRPr sz="1100" b="1">
+                <a:solidFill>
+                  <a:srgbClr val="FFFFFF"/>
+                </a:solidFill>
+              </a:defRPr>
+            </a:pPr>
+            <a:r>
+              <a:t>Editar Proposta</a:t>
+            </a:r>
+          </a:p>
+          <a:p>
+            <a:pPr algn="ctr">
+              <a:defRPr sz="800">
+                <a:solidFill>
+                  <a:srgbClr val="FFFFFF"/>
+                </a:solidFill>
+              </a:defRPr>
+            </a:pPr>
+            <a:r>
+              <a:t>Modal visual para</a:t>
+            </a:r>
+          </a:p>
+          <a:p>
+            <a:pPr algn="ctr">
+              <a:defRPr sz="800">
+                <a:solidFill>
+                  <a:srgbClr val="FFFFFF"/>
+                </a:solidFill>
+              </a:defRPr>
+            </a:pPr>
+            <a:r>
+              <a:t>ajustar valores</a:t>
+            </a:r>
+          </a:p>
+        </p:txBody>
+      </p:sp>
+      <p:sp>
+        <p:nvSpPr>
+          <p:cNvPr id="9" name="Rounded Rectangle 8"/>
           <p:cNvSpPr/>
           <p:nvPr/>
         </p:nvSpPr>
         <p:spPr>
           <a:xfrm>
-            <a:off x="9235440" y="1645920"/>
-            <a:ext cx="2011680" cy="777240"/>
+            <a:off x="9646920" y="914400"/>
+            <a:ext cx="1691640" cy="1280160"/>
           </a:xfrm>
           <a:prstGeom prst="roundRect">
             <a:avLst/>
           </a:prstGeom>
           <a:solidFill>
-            <a:srgbClr val="FFF7ED"/>
-          </a:solidFill>
-          <a:ln w="25400">
-            <a:solidFill>
-              <a:srgbClr val="EA580C"/>
-            </a:solidFill>
-          </a:ln>
-        </p:spPr>
-        <p:style>
-          <a:lnRef idx="1">
-            <a:schemeClr val="accent1"/>
-          </a:lnRef>
-          <a:fillRef idx="3">
-            <a:schemeClr val="accent1"/>
-          </a:fillRef>
-          <a:effectRef idx="2">
-            <a:schemeClr val="accent1"/>
-          </a:effectRef>
-          <a:fontRef idx="minor">
-            <a:schemeClr val="lt1"/>
-          </a:fontRef>
-        </p:style>
-        <p:txBody>
-          <a:bodyPr rtlCol="0" anchor="ctr" wrap="square"/>
-          <a:lstStyle/>
-          <a:p>
-            <a:pPr algn="l"/>
-            <a:r>
-              <a:rPr sz="1000" b="1">
-                <a:solidFill>
-                  <a:srgbClr val="1F2937"/>
-                </a:solidFill>
-              </a:rPr>
-              <a:t>5. Editar Proposta</a:t>
-            </a:r>
-          </a:p>
-          <a:p>
-            <a:pPr algn="l"/>
-            <a:r>
-              <a:rPr sz="700">
-                <a:solidFill>
-                  <a:srgbClr val="6B7280"/>
-                </a:solidFill>
-              </a:rPr>
-              <a:t>Modal visual para
-ajustar valores/itens</a:t>
-            </a:r>
-          </a:p>
-        </p:txBody>
-      </p:sp>
-      <p:sp>
-        <p:nvSpPr>
-          <p:cNvPr id="12" name="Down Arrow 11"/>
-          <p:cNvSpPr/>
-          <p:nvPr/>
-        </p:nvSpPr>
-        <p:spPr>
-          <a:xfrm>
-            <a:off x="10149840" y="2423160"/>
-            <a:ext cx="182880" cy="137160"/>
-          </a:xfrm>
-          <a:prstGeom prst="downArrow">
-            <a:avLst/>
-          </a:prstGeom>
-          <a:solidFill>
-            <a:srgbClr val="6B7280"/>
+            <a:srgbClr val="E74C3C"/>
           </a:solidFill>
           <a:ln>
             <a:noFill/>
@@ -3691,94 +3642,74 @@
           </a:fontRef>
         </p:style>
         <p:txBody>
-          <a:bodyPr rtlCol="0" anchor="ctr"/>
-          <a:lstStyle/>
-          <a:p>
-            <a:pPr algn="ctr"/>
-          </a:p>
-        </p:txBody>
-      </p:sp>
-      <p:sp>
-        <p:nvSpPr>
-          <p:cNvPr id="13" name="Rounded Rectangle 12"/>
+          <a:bodyPr rtlCol="0" anchor="ctr" wrap="square"/>
+          <a:lstStyle/>
+          <a:p>
+            <a:pPr algn="l">
+              <a:defRPr sz="1000" b="1">
+                <a:solidFill>
+                  <a:srgbClr val="FFFFFF"/>
+                </a:solidFill>
+              </a:defRPr>
+            </a:pPr>
+            <a:r>
+              <a:t>6</a:t>
+            </a:r>
+          </a:p>
+          <a:p>
+            <a:pPr algn="ctr">
+              <a:defRPr sz="1100" b="1">
+                <a:solidFill>
+                  <a:srgbClr val="FFFFFF"/>
+                </a:solidFill>
+              </a:defRPr>
+            </a:pPr>
+            <a:r>
+              <a:t>Enviar por Email</a:t>
+            </a:r>
+          </a:p>
+          <a:p>
+            <a:pPr algn="ctr">
+              <a:defRPr sz="800">
+                <a:solidFill>
+                  <a:srgbClr val="FFFFFF"/>
+                </a:solidFill>
+              </a:defRPr>
+            </a:pPr>
+            <a:r>
+              <a:t>Email + botoes</a:t>
+            </a:r>
+          </a:p>
+          <a:p>
+            <a:pPr algn="ctr">
+              <a:defRPr sz="800">
+                <a:solidFill>
+                  <a:srgbClr val="FFFFFF"/>
+                </a:solidFill>
+              </a:defRPr>
+            </a:pPr>
+            <a:r>
+              <a:t>Aprovar/Recusar</a:t>
+            </a:r>
+          </a:p>
+        </p:txBody>
+      </p:sp>
+      <p:sp>
+        <p:nvSpPr>
+          <p:cNvPr id="10" name="Rounded Rectangle 9"/>
           <p:cNvSpPr/>
           <p:nvPr/>
         </p:nvSpPr>
         <p:spPr>
           <a:xfrm>
-            <a:off x="274320" y="2560320"/>
-            <a:ext cx="2011680" cy="777240"/>
+            <a:off x="9646920" y="2560320"/>
+            <a:ext cx="1691640" cy="1280160"/>
           </a:xfrm>
           <a:prstGeom prst="roundRect">
             <a:avLst/>
           </a:prstGeom>
           <a:solidFill>
-            <a:srgbClr val="FEF2F2"/>
-          </a:solidFill>
-          <a:ln w="25400">
-            <a:solidFill>
-              <a:srgbClr val="DC2626"/>
-            </a:solidFill>
-          </a:ln>
-        </p:spPr>
-        <p:style>
-          <a:lnRef idx="1">
-            <a:schemeClr val="accent1"/>
-          </a:lnRef>
-          <a:fillRef idx="3">
-            <a:schemeClr val="accent1"/>
-          </a:fillRef>
-          <a:effectRef idx="2">
-            <a:schemeClr val="accent1"/>
-          </a:effectRef>
-          <a:fontRef idx="minor">
-            <a:schemeClr val="lt1"/>
-          </a:fontRef>
-        </p:style>
-        <p:txBody>
-          <a:bodyPr rtlCol="0" anchor="ctr" wrap="square"/>
-          <a:lstStyle/>
-          <a:p>
-            <a:pPr algn="l"/>
-            <a:r>
-              <a:rPr sz="1000" b="1">
-                <a:solidFill>
-                  <a:srgbClr val="1F2937"/>
-                </a:solidFill>
-              </a:rPr>
-              <a:t>10. Enviar COPSOQ</a:t>
-            </a:r>
-          </a:p>
-          <a:p>
-            <a:pPr algn="l"/>
-            <a:r>
-              <a:rPr sz="700">
-                <a:solidFill>
-                  <a:srgbClr val="6B7280"/>
-                </a:solidFill>
-              </a:rPr>
-              <a:t>Dispara questionarios
-por email</a:t>
-            </a:r>
-          </a:p>
-        </p:txBody>
-      </p:sp>
-      <p:sp>
-        <p:nvSpPr>
-          <p:cNvPr id="14" name="Right Arrow 13"/>
-          <p:cNvSpPr/>
-          <p:nvPr/>
-        </p:nvSpPr>
-        <p:spPr>
-          <a:xfrm>
-            <a:off x="2286000" y="2857500"/>
-            <a:ext cx="228600" cy="182880"/>
-          </a:xfrm>
-          <a:prstGeom prst="rightArrow">
-            <a:avLst/>
-          </a:prstGeom>
-          <a:solidFill>
-            <a:srgbClr val="6B7280"/>
+            <a:srgbClr val="E74C3C"/>
           </a:solidFill>
           <a:ln>
             <a:noFill/>
@@ -3799,94 +3730,74 @@
           </a:fontRef>
         </p:style>
         <p:txBody>
-          <a:bodyPr rtlCol="0" anchor="ctr"/>
-          <a:lstStyle/>
-          <a:p>
-            <a:pPr algn="ctr"/>
-          </a:p>
-        </p:txBody>
-      </p:sp>
-      <p:sp>
-        <p:nvSpPr>
-          <p:cNvPr id="15" name="Rounded Rectangle 14"/>
+          <a:bodyPr rtlCol="0" anchor="ctr" wrap="square"/>
+          <a:lstStyle/>
+          <a:p>
+            <a:pPr algn="l">
+              <a:defRPr sz="1000" b="1">
+                <a:solidFill>
+                  <a:srgbClr val="FFFFFF"/>
+                </a:solidFill>
+              </a:defRPr>
+            </a:pPr>
+            <a:r>
+              <a:t>7</a:t>
+            </a:r>
+          </a:p>
+          <a:p>
+            <a:pPr algn="ctr">
+              <a:defRPr sz="1100" b="1">
+                <a:solidFill>
+                  <a:srgbClr val="FFFFFF"/>
+                </a:solidFill>
+              </a:defRPr>
+            </a:pPr>
+            <a:r>
+              <a:t>Aprovacao Email</a:t>
+            </a:r>
+          </a:p>
+          <a:p>
+            <a:pPr algn="ctr">
+              <a:defRPr sz="800">
+                <a:solidFill>
+                  <a:srgbClr val="FFFFFF"/>
+                </a:solidFill>
+              </a:defRPr>
+            </a:pPr>
+            <a:r>
+              <a:t>Empresa aprova</a:t>
+            </a:r>
+          </a:p>
+          <a:p>
+            <a:pPr algn="ctr">
+              <a:defRPr sz="800">
+                <a:solidFill>
+                  <a:srgbClr val="FFFFFF"/>
+                </a:solidFill>
+              </a:defRPr>
+            </a:pPr>
+            <a:r>
+              <a:t>pelo email</a:t>
+            </a:r>
+          </a:p>
+        </p:txBody>
+      </p:sp>
+      <p:sp>
+        <p:nvSpPr>
+          <p:cNvPr id="11" name="Rounded Rectangle 10"/>
           <p:cNvSpPr/>
           <p:nvPr/>
         </p:nvSpPr>
         <p:spPr>
           <a:xfrm>
-            <a:off x="2514600" y="2560320"/>
-            <a:ext cx="2011680" cy="777240"/>
+            <a:off x="7772400" y="2560320"/>
+            <a:ext cx="1691640" cy="1280160"/>
           </a:xfrm>
           <a:prstGeom prst="roundRect">
             <a:avLst/>
           </a:prstGeom>
           <a:solidFill>
-            <a:srgbClr val="F5F3FF"/>
-          </a:solidFill>
-          <a:ln w="25400">
-            <a:solidFill>
-              <a:srgbClr val="7C3AED"/>
-            </a:solidFill>
-          </a:ln>
-        </p:spPr>
-        <p:style>
-          <a:lnRef idx="1">
-            <a:schemeClr val="accent1"/>
-          </a:lnRef>
-          <a:fillRef idx="3">
-            <a:schemeClr val="accent1"/>
-          </a:fillRef>
-          <a:effectRef idx="2">
-            <a:schemeClr val="accent1"/>
-          </a:effectRef>
-          <a:fontRef idx="minor">
-            <a:schemeClr val="lt1"/>
-          </a:fontRef>
-        </p:style>
-        <p:txBody>
-          <a:bodyPr rtlCol="0" anchor="ctr" wrap="square"/>
-          <a:lstStyle/>
-          <a:p>
-            <a:pPr algn="l"/>
-            <a:r>
-              <a:rPr sz="1000" b="1">
-                <a:solidFill>
-                  <a:srgbClr val="1F2937"/>
-                </a:solidFill>
-              </a:rPr>
-              <a:t>9. Cadastrar Pessoas</a:t>
-            </a:r>
-          </a:p>
-          <a:p>
-            <a:pPr algn="l"/>
-            <a:r>
-              <a:rPr sz="700">
-                <a:solidFill>
-                  <a:srgbClr val="6B7280"/>
-                </a:solidFill>
-              </a:rPr>
-              <a:t>Empresa cadastra setores
-e colaboradores</a:t>
-            </a:r>
-          </a:p>
-        </p:txBody>
-      </p:sp>
-      <p:sp>
-        <p:nvSpPr>
-          <p:cNvPr id="16" name="Right Arrow 15"/>
-          <p:cNvSpPr/>
-          <p:nvPr/>
-        </p:nvSpPr>
-        <p:spPr>
-          <a:xfrm>
-            <a:off x="4526280" y="2857500"/>
-            <a:ext cx="228600" cy="182880"/>
-          </a:xfrm>
-          <a:prstGeom prst="rightArrow">
-            <a:avLst/>
-          </a:prstGeom>
-          <a:solidFill>
-            <a:srgbClr val="6B7280"/>
+            <a:srgbClr val="27AE60"/>
           </a:solidFill>
           <a:ln>
             <a:noFill/>
@@ -3907,94 +3818,74 @@
           </a:fontRef>
         </p:style>
         <p:txBody>
-          <a:bodyPr rtlCol="0" anchor="ctr"/>
-          <a:lstStyle/>
-          <a:p>
-            <a:pPr algn="ctr"/>
-          </a:p>
-        </p:txBody>
-      </p:sp>
-      <p:sp>
-        <p:nvSpPr>
-          <p:cNvPr id="17" name="Rounded Rectangle 16"/>
+          <a:bodyPr rtlCol="0" anchor="ctr" wrap="square"/>
+          <a:lstStyle/>
+          <a:p>
+            <a:pPr algn="l">
+              <a:defRPr sz="1000" b="1">
+                <a:solidFill>
+                  <a:srgbClr val="FFFFFF"/>
+                </a:solidFill>
+              </a:defRPr>
+            </a:pPr>
+            <a:r>
+              <a:t>8</a:t>
+            </a:r>
+          </a:p>
+          <a:p>
+            <a:pPr algn="ctr">
+              <a:defRPr sz="1100" b="1">
+                <a:solidFill>
+                  <a:srgbClr val="FFFFFF"/>
+                </a:solidFill>
+              </a:defRPr>
+            </a:pPr>
+            <a:r>
+              <a:t>Criar Conta</a:t>
+            </a:r>
+          </a:p>
+          <a:p>
+            <a:pPr algn="ctr">
+              <a:defRPr sz="800">
+                <a:solidFill>
+                  <a:srgbClr val="FFFFFF"/>
+                </a:solidFill>
+              </a:defRPr>
+            </a:pPr>
+            <a:r>
+              <a:t>Auto-cria usuario</a:t>
+            </a:r>
+          </a:p>
+          <a:p>
+            <a:pPr algn="ctr">
+              <a:defRPr sz="800">
+                <a:solidFill>
+                  <a:srgbClr val="FFFFFF"/>
+                </a:solidFill>
+              </a:defRPr>
+            </a:pPr>
+            <a:r>
+              <a:t>+ credenciais</a:t>
+            </a:r>
+          </a:p>
+        </p:txBody>
+      </p:sp>
+      <p:sp>
+        <p:nvSpPr>
+          <p:cNvPr id="12" name="Rounded Rectangle 11"/>
           <p:cNvSpPr/>
           <p:nvPr/>
         </p:nvSpPr>
         <p:spPr>
           <a:xfrm>
-            <a:off x="4754880" y="2560320"/>
-            <a:ext cx="2011680" cy="777240"/>
+            <a:off x="5897880" y="2560320"/>
+            <a:ext cx="1691640" cy="1280160"/>
           </a:xfrm>
           <a:prstGeom prst="roundRect">
             <a:avLst/>
           </a:prstGeom>
           <a:solidFill>
-            <a:srgbClr val="F5F3FF"/>
-          </a:solidFill>
-          <a:ln w="25400">
-            <a:solidFill>
-              <a:srgbClr val="7C3AED"/>
-            </a:solidFill>
-          </a:ln>
-        </p:spPr>
-        <p:style>
-          <a:lnRef idx="1">
-            <a:schemeClr val="accent1"/>
-          </a:lnRef>
-          <a:fillRef idx="3">
-            <a:schemeClr val="accent1"/>
-          </a:fillRef>
-          <a:effectRef idx="2">
-            <a:schemeClr val="accent1"/>
-          </a:effectRef>
-          <a:fontRef idx="minor">
-            <a:schemeClr val="lt1"/>
-          </a:fontRef>
-        </p:style>
-        <p:txBody>
-          <a:bodyPr rtlCol="0" anchor="ctr" wrap="square"/>
-          <a:lstStyle/>
-          <a:p>
-            <a:pPr algn="l"/>
-            <a:r>
-              <a:rPr sz="1000" b="1">
-                <a:solidFill>
-                  <a:srgbClr val="1F2937"/>
-                </a:solidFill>
-              </a:rPr>
-              <a:t>8. Criar Conta</a:t>
-            </a:r>
-          </a:p>
-          <a:p>
-            <a:pPr algn="l"/>
-            <a:r>
-              <a:rPr sz="700">
-                <a:solidFill>
-                  <a:srgbClr val="6B7280"/>
-                </a:solidFill>
-              </a:rPr>
-              <a:t>Auto-cria usuario +
-envia credenciais</a:t>
-            </a:r>
-          </a:p>
-        </p:txBody>
-      </p:sp>
-      <p:sp>
-        <p:nvSpPr>
-          <p:cNvPr id="18" name="Right Arrow 17"/>
-          <p:cNvSpPr/>
-          <p:nvPr/>
-        </p:nvSpPr>
-        <p:spPr>
-          <a:xfrm>
-            <a:off x="6766560" y="2857500"/>
-            <a:ext cx="228600" cy="182880"/>
-          </a:xfrm>
-          <a:prstGeom prst="rightArrow">
-            <a:avLst/>
-          </a:prstGeom>
-          <a:solidFill>
-            <a:srgbClr val="6B7280"/>
+            <a:srgbClr val="27AE60"/>
           </a:solidFill>
           <a:ln>
             <a:noFill/>
@@ -4015,94 +3906,74 @@
           </a:fontRef>
         </p:style>
         <p:txBody>
-          <a:bodyPr rtlCol="0" anchor="ctr"/>
-          <a:lstStyle/>
-          <a:p>
-            <a:pPr algn="ctr"/>
-          </a:p>
-        </p:txBody>
-      </p:sp>
-      <p:sp>
-        <p:nvSpPr>
-          <p:cNvPr id="19" name="Rounded Rectangle 18"/>
+          <a:bodyPr rtlCol="0" anchor="ctr" wrap="square"/>
+          <a:lstStyle/>
+          <a:p>
+            <a:pPr algn="l">
+              <a:defRPr sz="1000" b="1">
+                <a:solidFill>
+                  <a:srgbClr val="FFFFFF"/>
+                </a:solidFill>
+              </a:defRPr>
+            </a:pPr>
+            <a:r>
+              <a:t>9</a:t>
+            </a:r>
+          </a:p>
+          <a:p>
+            <a:pPr algn="ctr">
+              <a:defRPr sz="1100" b="1">
+                <a:solidFill>
+                  <a:srgbClr val="FFFFFF"/>
+                </a:solidFill>
+              </a:defRPr>
+            </a:pPr>
+            <a:r>
+              <a:t>Cadastrar Pessoas</a:t>
+            </a:r>
+          </a:p>
+          <a:p>
+            <a:pPr algn="ctr">
+              <a:defRPr sz="800">
+                <a:solidFill>
+                  <a:srgbClr val="FFFFFF"/>
+                </a:solidFill>
+              </a:defRPr>
+            </a:pPr>
+            <a:r>
+              <a:t>Empresa cadastra</a:t>
+            </a:r>
+          </a:p>
+          <a:p>
+            <a:pPr algn="ctr">
+              <a:defRPr sz="800">
+                <a:solidFill>
+                  <a:srgbClr val="FFFFFF"/>
+                </a:solidFill>
+              </a:defRPr>
+            </a:pPr>
+            <a:r>
+              <a:t>setores/colaboradores</a:t>
+            </a:r>
+          </a:p>
+        </p:txBody>
+      </p:sp>
+      <p:sp>
+        <p:nvSpPr>
+          <p:cNvPr id="13" name="Rounded Rectangle 12"/>
           <p:cNvSpPr/>
           <p:nvPr/>
         </p:nvSpPr>
         <p:spPr>
           <a:xfrm>
-            <a:off x="6995160" y="2560320"/>
-            <a:ext cx="2011680" cy="777240"/>
+            <a:off x="4023360" y="2560320"/>
+            <a:ext cx="1691640" cy="1280160"/>
           </a:xfrm>
           <a:prstGeom prst="roundRect">
             <a:avLst/>
           </a:prstGeom>
           <a:solidFill>
-            <a:srgbClr val="DCFCE7"/>
-          </a:solidFill>
-          <a:ln w="25400">
-            <a:solidFill>
-              <a:srgbClr val="16A34A"/>
-            </a:solidFill>
-          </a:ln>
-        </p:spPr>
-        <p:style>
-          <a:lnRef idx="1">
-            <a:schemeClr val="accent1"/>
-          </a:lnRef>
-          <a:fillRef idx="3">
-            <a:schemeClr val="accent1"/>
-          </a:fillRef>
-          <a:effectRef idx="2">
-            <a:schemeClr val="accent1"/>
-          </a:effectRef>
-          <a:fontRef idx="minor">
-            <a:schemeClr val="lt1"/>
-          </a:fontRef>
-        </p:style>
-        <p:txBody>
-          <a:bodyPr rtlCol="0" anchor="ctr" wrap="square"/>
-          <a:lstStyle/>
-          <a:p>
-            <a:pPr algn="l"/>
-            <a:r>
-              <a:rPr sz="1000" b="1">
-                <a:solidFill>
-                  <a:srgbClr val="1F2937"/>
-                </a:solidFill>
-              </a:rPr>
-              <a:t>7. Aprovacao Email</a:t>
-            </a:r>
-          </a:p>
-          <a:p>
-            <a:pPr algn="l"/>
-            <a:r>
-              <a:rPr sz="700">
-                <a:solidFill>
-                  <a:srgbClr val="6B7280"/>
-                </a:solidFill>
-              </a:rPr>
-              <a:t>Empresa clica Aprovar
-no email recebido</a:t>
-            </a:r>
-          </a:p>
-        </p:txBody>
-      </p:sp>
-      <p:sp>
-        <p:nvSpPr>
-          <p:cNvPr id="20" name="Right Arrow 19"/>
-          <p:cNvSpPr/>
-          <p:nvPr/>
-        </p:nvSpPr>
-        <p:spPr>
-          <a:xfrm>
-            <a:off x="9006840" y="2857500"/>
-            <a:ext cx="228600" cy="182880"/>
-          </a:xfrm>
-          <a:prstGeom prst="rightArrow">
-            <a:avLst/>
-          </a:prstGeom>
-          <a:solidFill>
-            <a:srgbClr val="6B7280"/>
+            <a:srgbClr val="F39C12"/>
           </a:solidFill>
           <a:ln>
             <a:noFill/>
@@ -4123,94 +3994,74 @@
           </a:fontRef>
         </p:style>
         <p:txBody>
-          <a:bodyPr rtlCol="0" anchor="ctr"/>
-          <a:lstStyle/>
-          <a:p>
-            <a:pPr algn="ctr"/>
-          </a:p>
-        </p:txBody>
-      </p:sp>
-      <p:sp>
-        <p:nvSpPr>
-          <p:cNvPr id="21" name="Rounded Rectangle 20"/>
+          <a:bodyPr rtlCol="0" anchor="ctr" wrap="square"/>
+          <a:lstStyle/>
+          <a:p>
+            <a:pPr algn="l">
+              <a:defRPr sz="1000" b="1">
+                <a:solidFill>
+                  <a:srgbClr val="FFFFFF"/>
+                </a:solidFill>
+              </a:defRPr>
+            </a:pPr>
+            <a:r>
+              <a:t>10</a:t>
+            </a:r>
+          </a:p>
+          <a:p>
+            <a:pPr algn="ctr">
+              <a:defRPr sz="1100" b="1">
+                <a:solidFill>
+                  <a:srgbClr val="FFFFFF"/>
+                </a:solidFill>
+              </a:defRPr>
+            </a:pPr>
+            <a:r>
+              <a:t>Verificar Billing</a:t>
+            </a:r>
+          </a:p>
+          <a:p>
+            <a:pPr algn="ctr">
+              <a:defRPr sz="800">
+                <a:solidFill>
+                  <a:srgbClr val="FFFFFF"/>
+                </a:solidFill>
+              </a:defRPr>
+            </a:pPr>
+            <a:r>
+              <a:t>Verifica excedentes</a:t>
+            </a:r>
+          </a:p>
+          <a:p>
+            <a:pPr algn="ctr">
+              <a:defRPr sz="800">
+                <a:solidFill>
+                  <a:srgbClr val="FFFFFF"/>
+                </a:solidFill>
+              </a:defRPr>
+            </a:pPr>
+            <a:r>
+              <a:t>PIX/Cartao/Creditos</a:t>
+            </a:r>
+          </a:p>
+        </p:txBody>
+      </p:sp>
+      <p:sp>
+        <p:nvSpPr>
+          <p:cNvPr id="14" name="Rounded Rectangle 13"/>
           <p:cNvSpPr/>
           <p:nvPr/>
         </p:nvSpPr>
         <p:spPr>
           <a:xfrm>
-            <a:off x="9235440" y="2560320"/>
-            <a:ext cx="2011680" cy="777240"/>
+            <a:off x="2148840" y="2560320"/>
+            <a:ext cx="1691640" cy="1280160"/>
           </a:xfrm>
           <a:prstGeom prst="roundRect">
             <a:avLst/>
           </a:prstGeom>
           <a:solidFill>
-            <a:srgbClr val="DCFCE7"/>
-          </a:solidFill>
-          <a:ln w="25400">
-            <a:solidFill>
-              <a:srgbClr val="16A34A"/>
-            </a:solidFill>
-          </a:ln>
-        </p:spPr>
-        <p:style>
-          <a:lnRef idx="1">
-            <a:schemeClr val="accent1"/>
-          </a:lnRef>
-          <a:fillRef idx="3">
-            <a:schemeClr val="accent1"/>
-          </a:fillRef>
-          <a:effectRef idx="2">
-            <a:schemeClr val="accent1"/>
-          </a:effectRef>
-          <a:fontRef idx="minor">
-            <a:schemeClr val="lt1"/>
-          </a:fontRef>
-        </p:style>
-        <p:txBody>
-          <a:bodyPr rtlCol="0" anchor="ctr" wrap="square"/>
-          <a:lstStyle/>
-          <a:p>
-            <a:pPr algn="l"/>
-            <a:r>
-              <a:rPr sz="1000" b="1">
-                <a:solidFill>
-                  <a:srgbClr val="1F2937"/>
-                </a:solidFill>
-              </a:rPr>
-              <a:t>6. Enviar por Email</a:t>
-            </a:r>
-          </a:p>
-          <a:p>
-            <a:pPr algn="l"/>
-            <a:r>
-              <a:rPr sz="700">
-                <a:solidFill>
-                  <a:srgbClr val="6B7280"/>
-                </a:solidFill>
-              </a:rPr>
-              <a:t>Email com proposta
-+ botoes Aprovar/Recusar</a:t>
-            </a:r>
-          </a:p>
-        </p:txBody>
-      </p:sp>
-      <p:sp>
-        <p:nvSpPr>
-          <p:cNvPr id="22" name="Down Arrow 21"/>
-          <p:cNvSpPr/>
-          <p:nvPr/>
-        </p:nvSpPr>
-        <p:spPr>
-          <a:xfrm>
-            <a:off x="1188720" y="3337560"/>
-            <a:ext cx="182880" cy="137160"/>
-          </a:xfrm>
-          <a:prstGeom prst="downArrow">
-            <a:avLst/>
-          </a:prstGeom>
-          <a:solidFill>
-            <a:srgbClr val="6B7280"/>
+            <a:srgbClr val="8E44AD"/>
           </a:solidFill>
           <a:ln>
             <a:noFill/>
@@ -4231,94 +4082,74 @@
           </a:fontRef>
         </p:style>
         <p:txBody>
-          <a:bodyPr rtlCol="0" anchor="ctr"/>
-          <a:lstStyle/>
-          <a:p>
-            <a:pPr algn="ctr"/>
-          </a:p>
-        </p:txBody>
-      </p:sp>
-      <p:sp>
-        <p:nvSpPr>
-          <p:cNvPr id="23" name="Rounded Rectangle 22"/>
+          <a:bodyPr rtlCol="0" anchor="ctr" wrap="square"/>
+          <a:lstStyle/>
+          <a:p>
+            <a:pPr algn="l">
+              <a:defRPr sz="1000" b="1">
+                <a:solidFill>
+                  <a:srgbClr val="FFFFFF"/>
+                </a:solidFill>
+              </a:defRPr>
+            </a:pPr>
+            <a:r>
+              <a:t>11</a:t>
+            </a:r>
+          </a:p>
+          <a:p>
+            <a:pPr algn="ctr">
+              <a:defRPr sz="1100" b="1">
+                <a:solidFill>
+                  <a:srgbClr val="FFFFFF"/>
+                </a:solidFill>
+              </a:defRPr>
+            </a:pPr>
+            <a:r>
+              <a:t>Enviar COPSOQ</a:t>
+            </a:r>
+          </a:p>
+          <a:p>
+            <a:pPr algn="ctr">
+              <a:defRPr sz="800">
+                <a:solidFill>
+                  <a:srgbClr val="FFFFFF"/>
+                </a:solidFill>
+              </a:defRPr>
+            </a:pPr>
+            <a:r>
+              <a:t>Dispara questionarios</a:t>
+            </a:r>
+          </a:p>
+          <a:p>
+            <a:pPr algn="ctr">
+              <a:defRPr sz="800">
+                <a:solidFill>
+                  <a:srgbClr val="FFFFFF"/>
+                </a:solidFill>
+              </a:defRPr>
+            </a:pPr>
+            <a:r>
+              <a:t>por email</a:t>
+            </a:r>
+          </a:p>
+        </p:txBody>
+      </p:sp>
+      <p:sp>
+        <p:nvSpPr>
+          <p:cNvPr id="15" name="Rounded Rectangle 14"/>
           <p:cNvSpPr/>
           <p:nvPr/>
         </p:nvSpPr>
         <p:spPr>
           <a:xfrm>
-            <a:off x="274320" y="3474720"/>
-            <a:ext cx="2011680" cy="777240"/>
+            <a:off x="274320" y="2560320"/>
+            <a:ext cx="1691640" cy="1280160"/>
           </a:xfrm>
           <a:prstGeom prst="roundRect">
             <a:avLst/>
           </a:prstGeom>
           <a:solidFill>
-            <a:srgbClr val="FEF2F2"/>
-          </a:solidFill>
-          <a:ln w="25400">
-            <a:solidFill>
-              <a:srgbClr val="DC2626"/>
-            </a:solidFill>
-          </a:ln>
-        </p:spPr>
-        <p:style>
-          <a:lnRef idx="1">
-            <a:schemeClr val="accent1"/>
-          </a:lnRef>
-          <a:fillRef idx="3">
-            <a:schemeClr val="accent1"/>
-          </a:fillRef>
-          <a:effectRef idx="2">
-            <a:schemeClr val="accent1"/>
-          </a:effectRef>
-          <a:fontRef idx="minor">
-            <a:schemeClr val="lt1"/>
-          </a:fontRef>
-        </p:style>
-        <p:txBody>
-          <a:bodyPr rtlCol="0" anchor="ctr" wrap="square"/>
-          <a:lstStyle/>
-          <a:p>
-            <a:pPr algn="l"/>
-            <a:r>
-              <a:rPr sz="1000" b="1">
-                <a:solidFill>
-                  <a:srgbClr val="1F2937"/>
-                </a:solidFill>
-              </a:rPr>
-              <a:t>11. Respostas COPSOQ</a:t>
-            </a:r>
-          </a:p>
-          <a:p>
-            <a:pPr algn="l"/>
-            <a:r>
-              <a:rPr sz="700">
-                <a:solidFill>
-                  <a:srgbClr val="6B7280"/>
-                </a:solidFill>
-              </a:rPr>
-              <a:t>Colaboradores respondem
-(anonimo, 7 dias)</a:t>
-            </a:r>
-          </a:p>
-        </p:txBody>
-      </p:sp>
-      <p:sp>
-        <p:nvSpPr>
-          <p:cNvPr id="24" name="Right Arrow 23"/>
-          <p:cNvSpPr/>
-          <p:nvPr/>
-        </p:nvSpPr>
-        <p:spPr>
-          <a:xfrm>
-            <a:off x="2286000" y="3771900"/>
-            <a:ext cx="228600" cy="182880"/>
-          </a:xfrm>
-          <a:prstGeom prst="rightArrow">
-            <a:avLst/>
-          </a:prstGeom>
-          <a:solidFill>
-            <a:srgbClr val="6B7280"/>
+            <a:srgbClr val="8E44AD"/>
           </a:solidFill>
           <a:ln>
             <a:noFill/>
@@ -4339,94 +4170,74 @@
           </a:fontRef>
         </p:style>
         <p:txBody>
-          <a:bodyPr rtlCol="0" anchor="ctr"/>
-          <a:lstStyle/>
-          <a:p>
-            <a:pPr algn="ctr"/>
-          </a:p>
-        </p:txBody>
-      </p:sp>
-      <p:sp>
-        <p:nvSpPr>
-          <p:cNvPr id="25" name="Rounded Rectangle 24"/>
+          <a:bodyPr rtlCol="0" anchor="ctr" wrap="square"/>
+          <a:lstStyle/>
+          <a:p>
+            <a:pPr algn="l">
+              <a:defRPr sz="1000" b="1">
+                <a:solidFill>
+                  <a:srgbClr val="FFFFFF"/>
+                </a:solidFill>
+              </a:defRPr>
+            </a:pPr>
+            <a:r>
+              <a:t>12</a:t>
+            </a:r>
+          </a:p>
+          <a:p>
+            <a:pPr algn="ctr">
+              <a:defRPr sz="1100" b="1">
+                <a:solidFill>
+                  <a:srgbClr val="FFFFFF"/>
+                </a:solidFill>
+              </a:defRPr>
+            </a:pPr>
+            <a:r>
+              <a:t>Respostas COPSOQ</a:t>
+            </a:r>
+          </a:p>
+          <a:p>
+            <a:pPr algn="ctr">
+              <a:defRPr sz="800">
+                <a:solidFill>
+                  <a:srgbClr val="FFFFFF"/>
+                </a:solidFill>
+              </a:defRPr>
+            </a:pPr>
+            <a:r>
+              <a:t>Colaboradores</a:t>
+            </a:r>
+          </a:p>
+          <a:p>
+            <a:pPr algn="ctr">
+              <a:defRPr sz="800">
+                <a:solidFill>
+                  <a:srgbClr val="FFFFFF"/>
+                </a:solidFill>
+              </a:defRPr>
+            </a:pPr>
+            <a:r>
+              <a:t>respondem (7 dias)</a:t>
+            </a:r>
+          </a:p>
+        </p:txBody>
+      </p:sp>
+      <p:sp>
+        <p:nvSpPr>
+          <p:cNvPr id="16" name="Rounded Rectangle 15"/>
           <p:cNvSpPr/>
           <p:nvPr/>
         </p:nvSpPr>
         <p:spPr>
           <a:xfrm>
-            <a:off x="2514600" y="3474720"/>
-            <a:ext cx="2011680" cy="777240"/>
+            <a:off x="274320" y="4206240"/>
+            <a:ext cx="1691640" cy="1280160"/>
           </a:xfrm>
           <a:prstGeom prst="roundRect">
             <a:avLst/>
           </a:prstGeom>
           <a:solidFill>
-            <a:srgbClr val="FFFBEB"/>
-          </a:solidFill>
-          <a:ln w="25400">
-            <a:solidFill>
-              <a:srgbClr val="D97706"/>
-            </a:solidFill>
-          </a:ln>
-        </p:spPr>
-        <p:style>
-          <a:lnRef idx="1">
-            <a:schemeClr val="accent1"/>
-          </a:lnRef>
-          <a:fillRef idx="3">
-            <a:schemeClr val="accent1"/>
-          </a:fillRef>
-          <a:effectRef idx="2">
-            <a:schemeClr val="accent1"/>
-          </a:effectRef>
-          <a:fontRef idx="minor">
-            <a:schemeClr val="lt1"/>
-          </a:fontRef>
-        </p:style>
-        <p:txBody>
-          <a:bodyPr rtlCol="0" anchor="ctr" wrap="square"/>
-          <a:lstStyle/>
-          <a:p>
-            <a:pPr algn="l"/>
-            <a:r>
-              <a:rPr sz="1000" b="1">
-                <a:solidFill>
-                  <a:srgbClr val="1F2937"/>
-                </a:solidFill>
-              </a:rPr>
-              <a:t>12. Gerar Relatorio</a:t>
-            </a:r>
-          </a:p>
-          <a:p>
-            <a:pPr algn="l"/>
-            <a:r>
-              <a:rPr sz="700">
-                <a:solidFill>
-                  <a:srgbClr val="6B7280"/>
-                </a:solidFill>
-              </a:rPr>
-              <a:t>Analise automatica
-dos resultados</a:t>
-            </a:r>
-          </a:p>
-        </p:txBody>
-      </p:sp>
-      <p:sp>
-        <p:nvSpPr>
-          <p:cNvPr id="26" name="Right Arrow 25"/>
-          <p:cNvSpPr/>
-          <p:nvPr/>
-        </p:nvSpPr>
-        <p:spPr>
-          <a:xfrm>
-            <a:off x="4526280" y="3771900"/>
-            <a:ext cx="228600" cy="182880"/>
-          </a:xfrm>
-          <a:prstGeom prst="rightArrow">
-            <a:avLst/>
-          </a:prstGeom>
-          <a:solidFill>
-            <a:srgbClr val="6B7280"/>
+            <a:srgbClr val="8E44AD"/>
           </a:solidFill>
           <a:ln>
             <a:noFill/>
@@ -4447,94 +4258,74 @@
           </a:fontRef>
         </p:style>
         <p:txBody>
-          <a:bodyPr rtlCol="0" anchor="ctr"/>
-          <a:lstStyle/>
-          <a:p>
-            <a:pPr algn="ctr"/>
-          </a:p>
-        </p:txBody>
-      </p:sp>
-      <p:sp>
-        <p:nvSpPr>
-          <p:cNvPr id="27" name="Rounded Rectangle 26"/>
+          <a:bodyPr rtlCol="0" anchor="ctr" wrap="square"/>
+          <a:lstStyle/>
+          <a:p>
+            <a:pPr algn="l">
+              <a:defRPr sz="1000" b="1">
+                <a:solidFill>
+                  <a:srgbClr val="FFFFFF"/>
+                </a:solidFill>
+              </a:defRPr>
+            </a:pPr>
+            <a:r>
+              <a:t>13</a:t>
+            </a:r>
+          </a:p>
+          <a:p>
+            <a:pPr algn="ctr">
+              <a:defRPr sz="1100" b="1">
+                <a:solidFill>
+                  <a:srgbClr val="FFFFFF"/>
+                </a:solidFill>
+              </a:defRPr>
+            </a:pPr>
+            <a:r>
+              <a:t>Gerar Relatorio</a:t>
+            </a:r>
+          </a:p>
+          <a:p>
+            <a:pPr algn="ctr">
+              <a:defRPr sz="800">
+                <a:solidFill>
+                  <a:srgbClr val="FFFFFF"/>
+                </a:solidFill>
+              </a:defRPr>
+            </a:pPr>
+            <a:r>
+              <a:t>Analise automatica</a:t>
+            </a:r>
+          </a:p>
+          <a:p>
+            <a:pPr algn="ctr">
+              <a:defRPr sz="800">
+                <a:solidFill>
+                  <a:srgbClr val="FFFFFF"/>
+                </a:solidFill>
+              </a:defRPr>
+            </a:pPr>
+            <a:r>
+              <a:t>resultados COPSOQ</a:t>
+            </a:r>
+          </a:p>
+        </p:txBody>
+      </p:sp>
+      <p:sp>
+        <p:nvSpPr>
+          <p:cNvPr id="17" name="Rounded Rectangle 16"/>
           <p:cNvSpPr/>
           <p:nvPr/>
         </p:nvSpPr>
         <p:spPr>
           <a:xfrm>
-            <a:off x="4754880" y="3474720"/>
-            <a:ext cx="2011680" cy="777240"/>
+            <a:off x="2148840" y="4206240"/>
+            <a:ext cx="1691640" cy="1280160"/>
           </a:xfrm>
           <a:prstGeom prst="roundRect">
             <a:avLst/>
           </a:prstGeom>
           <a:solidFill>
-            <a:srgbClr val="FFFBEB"/>
-          </a:solidFill>
-          <a:ln w="25400">
-            <a:solidFill>
-              <a:srgbClr val="D97706"/>
-            </a:solidFill>
-          </a:ln>
-        </p:spPr>
-        <p:style>
-          <a:lnRef idx="1">
-            <a:schemeClr val="accent1"/>
-          </a:lnRef>
-          <a:fillRef idx="3">
-            <a:schemeClr val="accent1"/>
-          </a:fillRef>
-          <a:effectRef idx="2">
-            <a:schemeClr val="accent1"/>
-          </a:effectRef>
-          <a:fontRef idx="minor">
-            <a:schemeClr val="lt1"/>
-          </a:fontRef>
-        </p:style>
-        <p:txBody>
-          <a:bodyPr rtlCol="0" anchor="ctr" wrap="square"/>
-          <a:lstStyle/>
-          <a:p>
-            <a:pPr algn="l"/>
-            <a:r>
-              <a:rPr sz="1000" b="1">
-                <a:solidFill>
-                  <a:srgbClr val="1F2937"/>
-                </a:solidFill>
-              </a:rPr>
-              <a:t>13. Inventario Riscos</a:t>
-            </a:r>
-          </a:p>
-          <a:p>
-            <a:pPr algn="l"/>
-            <a:r>
-              <a:rPr sz="700">
-                <a:solidFill>
-                  <a:srgbClr val="6B7280"/>
-                </a:solidFill>
-              </a:rPr>
-              <a:t>Mapeamento completo
-de riscos psicossociais</a:t>
-            </a:r>
-          </a:p>
-        </p:txBody>
-      </p:sp>
-      <p:sp>
-        <p:nvSpPr>
-          <p:cNvPr id="28" name="Right Arrow 27"/>
-          <p:cNvSpPr/>
-          <p:nvPr/>
-        </p:nvSpPr>
-        <p:spPr>
-          <a:xfrm>
-            <a:off x="6766560" y="3771900"/>
-            <a:ext cx="228600" cy="182880"/>
-          </a:xfrm>
-          <a:prstGeom prst="rightArrow">
-            <a:avLst/>
-          </a:prstGeom>
-          <a:solidFill>
-            <a:srgbClr val="6B7280"/>
+            <a:srgbClr val="2C3E50"/>
           </a:solidFill>
           <a:ln>
             <a:noFill/>
@@ -4555,94 +4346,74 @@
           </a:fontRef>
         </p:style>
         <p:txBody>
-          <a:bodyPr rtlCol="0" anchor="ctr"/>
-          <a:lstStyle/>
-          <a:p>
-            <a:pPr algn="ctr"/>
-          </a:p>
-        </p:txBody>
-      </p:sp>
-      <p:sp>
-        <p:nvSpPr>
-          <p:cNvPr id="29" name="Rounded Rectangle 28"/>
+          <a:bodyPr rtlCol="0" anchor="ctr" wrap="square"/>
+          <a:lstStyle/>
+          <a:p>
+            <a:pPr algn="l">
+              <a:defRPr sz="1000" b="1">
+                <a:solidFill>
+                  <a:srgbClr val="FFFFFF"/>
+                </a:solidFill>
+              </a:defRPr>
+            </a:pPr>
+            <a:r>
+              <a:t>14</a:t>
+            </a:r>
+          </a:p>
+          <a:p>
+            <a:pPr algn="ctr">
+              <a:defRPr sz="1100" b="1">
+                <a:solidFill>
+                  <a:srgbClr val="FFFFFF"/>
+                </a:solidFill>
+              </a:defRPr>
+            </a:pPr>
+            <a:r>
+              <a:t>Inventario Riscos</a:t>
+            </a:r>
+          </a:p>
+          <a:p>
+            <a:pPr algn="ctr">
+              <a:defRPr sz="800">
+                <a:solidFill>
+                  <a:srgbClr val="FFFFFF"/>
+                </a:solidFill>
+              </a:defRPr>
+            </a:pPr>
+            <a:r>
+              <a:t>Mapeamento riscos</a:t>
+            </a:r>
+          </a:p>
+          <a:p>
+            <a:pPr algn="ctr">
+              <a:defRPr sz="800">
+                <a:solidFill>
+                  <a:srgbClr val="FFFFFF"/>
+                </a:solidFill>
+              </a:defRPr>
+            </a:pPr>
+            <a:r>
+              <a:t>psicossociais</a:t>
+            </a:r>
+          </a:p>
+        </p:txBody>
+      </p:sp>
+      <p:sp>
+        <p:nvSpPr>
+          <p:cNvPr id="18" name="Rounded Rectangle 17"/>
           <p:cNvSpPr/>
           <p:nvPr/>
         </p:nvSpPr>
         <p:spPr>
           <a:xfrm>
-            <a:off x="6995160" y="3474720"/>
-            <a:ext cx="2011680" cy="777240"/>
+            <a:off x="4023360" y="4206240"/>
+            <a:ext cx="1691640" cy="1280160"/>
           </a:xfrm>
           <a:prstGeom prst="roundRect">
             <a:avLst/>
           </a:prstGeom>
           <a:solidFill>
-            <a:srgbClr val="FFFBEB"/>
-          </a:solidFill>
-          <a:ln w="25400">
-            <a:solidFill>
-              <a:srgbClr val="D97706"/>
-            </a:solidFill>
-          </a:ln>
-        </p:spPr>
-        <p:style>
-          <a:lnRef idx="1">
-            <a:schemeClr val="accent1"/>
-          </a:lnRef>
-          <a:fillRef idx="3">
-            <a:schemeClr val="accent1"/>
-          </a:fillRef>
-          <a:effectRef idx="2">
-            <a:schemeClr val="accent1"/>
-          </a:effectRef>
-          <a:fontRef idx="minor">
-            <a:schemeClr val="lt1"/>
-          </a:fontRef>
-        </p:style>
-        <p:txBody>
-          <a:bodyPr rtlCol="0" anchor="ctr" wrap="square"/>
-          <a:lstStyle/>
-          <a:p>
-            <a:pPr algn="l"/>
-            <a:r>
-              <a:rPr sz="1000" b="1">
-                <a:solidFill>
-                  <a:srgbClr val="1F2937"/>
-                </a:solidFill>
-              </a:rPr>
-              <a:t>14. Plano de Acao</a:t>
-            </a:r>
-          </a:p>
-          <a:p>
-            <a:pPr algn="l"/>
-            <a:r>
-              <a:rPr sz="700">
-                <a:solidFill>
-                  <a:srgbClr val="6B7280"/>
-                </a:solidFill>
-              </a:rPr>
-              <a:t>Acoes corretivas com
-prazos e responsaveis</a:t>
-            </a:r>
-          </a:p>
-        </p:txBody>
-      </p:sp>
-      <p:sp>
-        <p:nvSpPr>
-          <p:cNvPr id="30" name="Right Arrow 29"/>
-          <p:cNvSpPr/>
-          <p:nvPr/>
-        </p:nvSpPr>
-        <p:spPr>
-          <a:xfrm>
-            <a:off x="9006840" y="3771900"/>
-            <a:ext cx="228600" cy="182880"/>
-          </a:xfrm>
-          <a:prstGeom prst="rightArrow">
-            <a:avLst/>
-          </a:prstGeom>
-          <a:solidFill>
-            <a:srgbClr val="6B7280"/>
+            <a:srgbClr val="2C3E50"/>
           </a:solidFill>
           <a:ln>
             <a:noFill/>
@@ -4663,94 +4434,74 @@
           </a:fontRef>
         </p:style>
         <p:txBody>
-          <a:bodyPr rtlCol="0" anchor="ctr"/>
-          <a:lstStyle/>
-          <a:p>
-            <a:pPr algn="ctr"/>
-          </a:p>
-        </p:txBody>
-      </p:sp>
-      <p:sp>
-        <p:nvSpPr>
-          <p:cNvPr id="31" name="Rounded Rectangle 30"/>
+          <a:bodyPr rtlCol="0" anchor="ctr" wrap="square"/>
+          <a:lstStyle/>
+          <a:p>
+            <a:pPr algn="l">
+              <a:defRPr sz="1000" b="1">
+                <a:solidFill>
+                  <a:srgbClr val="FFFFFF"/>
+                </a:solidFill>
+              </a:defRPr>
+            </a:pPr>
+            <a:r>
+              <a:t>15</a:t>
+            </a:r>
+          </a:p>
+          <a:p>
+            <a:pPr algn="ctr">
+              <a:defRPr sz="1100" b="1">
+                <a:solidFill>
+                  <a:srgbClr val="FFFFFF"/>
+                </a:solidFill>
+              </a:defRPr>
+            </a:pPr>
+            <a:r>
+              <a:t>Plano de Acao</a:t>
+            </a:r>
+          </a:p>
+          <a:p>
+            <a:pPr algn="ctr">
+              <a:defRPr sz="800">
+                <a:solidFill>
+                  <a:srgbClr val="FFFFFF"/>
+                </a:solidFill>
+              </a:defRPr>
+            </a:pPr>
+            <a:r>
+              <a:t>Acoes corretivas</a:t>
+            </a:r>
+          </a:p>
+          <a:p>
+            <a:pPr algn="ctr">
+              <a:defRPr sz="800">
+                <a:solidFill>
+                  <a:srgbClr val="FFFFFF"/>
+                </a:solidFill>
+              </a:defRPr>
+            </a:pPr>
+            <a:r>
+              <a:t>prazos/responsaveis</a:t>
+            </a:r>
+          </a:p>
+        </p:txBody>
+      </p:sp>
+      <p:sp>
+        <p:nvSpPr>
+          <p:cNvPr id="19" name="Rounded Rectangle 18"/>
           <p:cNvSpPr/>
           <p:nvPr/>
         </p:nvSpPr>
         <p:spPr>
           <a:xfrm>
-            <a:off x="9235440" y="3474720"/>
-            <a:ext cx="2011680" cy="777240"/>
+            <a:off x="5897880" y="4206240"/>
+            <a:ext cx="1691640" cy="1280160"/>
           </a:xfrm>
           <a:prstGeom prst="roundRect">
             <a:avLst/>
           </a:prstGeom>
           <a:solidFill>
-            <a:srgbClr val="DCFCE7"/>
-          </a:solidFill>
-          <a:ln w="25400">
-            <a:solidFill>
-              <a:srgbClr val="16A34A"/>
-            </a:solidFill>
-          </a:ln>
-        </p:spPr>
-        <p:style>
-          <a:lnRef idx="1">
-            <a:schemeClr val="accent1"/>
-          </a:lnRef>
-          <a:fillRef idx="3">
-            <a:schemeClr val="accent1"/>
-          </a:fillRef>
-          <a:effectRef idx="2">
-            <a:schemeClr val="accent1"/>
-          </a:effectRef>
-          <a:fontRef idx="minor">
-            <a:schemeClr val="lt1"/>
-          </a:fontRef>
-        </p:style>
-        <p:txBody>
-          <a:bodyPr rtlCol="0" anchor="ctr" wrap="square"/>
-          <a:lstStyle/>
-          <a:p>
-            <a:pPr algn="l"/>
-            <a:r>
-              <a:rPr sz="1000" b="1">
-                <a:solidFill>
-                  <a:srgbClr val="1F2937"/>
-                </a:solidFill>
-              </a:rPr>
-              <a:t>15. Proposta Final</a:t>
-            </a:r>
-          </a:p>
-          <a:p>
-            <a:pPr algn="l"/>
-            <a:r>
-              <a:rPr sz="700">
-                <a:solidFill>
-                  <a:srgbClr val="6B7280"/>
-                </a:solidFill>
-              </a:rPr>
-              <a:t>Proposta definitiva com
-valores reais do servico</a:t>
-            </a:r>
-          </a:p>
-        </p:txBody>
-      </p:sp>
-      <p:sp>
-        <p:nvSpPr>
-          <p:cNvPr id="32" name="Down Arrow 31"/>
-          <p:cNvSpPr/>
-          <p:nvPr/>
-        </p:nvSpPr>
-        <p:spPr>
-          <a:xfrm>
-            <a:off x="10149840" y="4251960"/>
-            <a:ext cx="182880" cy="137160"/>
-          </a:xfrm>
-          <a:prstGeom prst="downArrow">
-            <a:avLst/>
-          </a:prstGeom>
-          <a:solidFill>
-            <a:srgbClr val="6B7280"/>
+            <a:srgbClr val="4A90D9"/>
           </a:solidFill>
           <a:ln>
             <a:noFill/>
@@ -4771,288 +4522,74 @@
           </a:fontRef>
         </p:style>
         <p:txBody>
-          <a:bodyPr rtlCol="0" anchor="ctr"/>
-          <a:lstStyle/>
-          <a:p>
-            <a:pPr algn="ctr"/>
-          </a:p>
-        </p:txBody>
-      </p:sp>
-      <p:sp>
-        <p:nvSpPr>
-          <p:cNvPr id="33" name="Rounded Rectangle 32"/>
+          <a:bodyPr rtlCol="0" anchor="ctr" wrap="square"/>
+          <a:lstStyle/>
+          <a:p>
+            <a:pPr algn="l">
+              <a:defRPr sz="1000" b="1">
+                <a:solidFill>
+                  <a:srgbClr val="FFFFFF"/>
+                </a:solidFill>
+              </a:defRPr>
+            </a:pPr>
+            <a:r>
+              <a:t>16</a:t>
+            </a:r>
+          </a:p>
+          <a:p>
+            <a:pPr algn="ctr">
+              <a:defRPr sz="1100" b="1">
+                <a:solidFill>
+                  <a:srgbClr val="FFFFFF"/>
+                </a:solidFill>
+              </a:defRPr>
+            </a:pPr>
+            <a:r>
+              <a:t>Proposta Final</a:t>
+            </a:r>
+          </a:p>
+          <a:p>
+            <a:pPr algn="ctr">
+              <a:defRPr sz="800">
+                <a:solidFill>
+                  <a:srgbClr val="FFFFFF"/>
+                </a:solidFill>
+              </a:defRPr>
+            </a:pPr>
+            <a:r>
+              <a:t>Proposta definitiva</a:t>
+            </a:r>
+          </a:p>
+          <a:p>
+            <a:pPr algn="ctr">
+              <a:defRPr sz="800">
+                <a:solidFill>
+                  <a:srgbClr val="FFFFFF"/>
+                </a:solidFill>
+              </a:defRPr>
+            </a:pPr>
+            <a:r>
+              <a:t>valores reais</a:t>
+            </a:r>
+          </a:p>
+        </p:txBody>
+      </p:sp>
+      <p:sp>
+        <p:nvSpPr>
+          <p:cNvPr id="20" name="Rounded Rectangle 19"/>
           <p:cNvSpPr/>
           <p:nvPr/>
         </p:nvSpPr>
         <p:spPr>
           <a:xfrm>
-            <a:off x="9235440" y="4389120"/>
-            <a:ext cx="2011680" cy="777240"/>
+            <a:off x="7772400" y="4206240"/>
+            <a:ext cx="1691640" cy="1280160"/>
           </a:xfrm>
           <a:prstGeom prst="roundRect">
             <a:avLst/>
           </a:prstGeom>
           <a:solidFill>
-            <a:srgbClr val="DBEAFE"/>
-          </a:solidFill>
-          <a:ln w="25400">
-            <a:solidFill>
-              <a:srgbClr val="1E40AF"/>
-            </a:solidFill>
-          </a:ln>
-        </p:spPr>
-        <p:style>
-          <a:lnRef idx="1">
-            <a:schemeClr val="accent1"/>
-          </a:lnRef>
-          <a:fillRef idx="3">
-            <a:schemeClr val="accent1"/>
-          </a:fillRef>
-          <a:effectRef idx="2">
-            <a:schemeClr val="accent1"/>
-          </a:effectRef>
-          <a:fontRef idx="minor">
-            <a:schemeClr val="lt1"/>
-          </a:fontRef>
-        </p:style>
-        <p:txBody>
-          <a:bodyPr rtlCol="0" anchor="ctr" wrap="square"/>
-          <a:lstStyle/>
-          <a:p>
-            <a:pPr algn="l"/>
-            <a:r>
-              <a:rPr sz="1000" b="1">
-                <a:solidFill>
-                  <a:srgbClr val="1F2937"/>
-                </a:solidFill>
-              </a:rPr>
-              <a:t>18. Entrega Final</a:t>
-            </a:r>
-          </a:p>
-          <a:p>
-            <a:pPr algn="l"/>
-            <a:r>
-              <a:rPr sz="700">
-                <a:solidFill>
-                  <a:srgbClr val="6B7280"/>
-                </a:solidFill>
-              </a:rPr>
-              <a:t>7 PDFs entregues:
-Proposta, COPSOQ, etc.</a:t>
-            </a:r>
-          </a:p>
-        </p:txBody>
-      </p:sp>
-      <p:sp>
-        <p:nvSpPr>
-          <p:cNvPr id="34" name="Rounded Rectangle 33"/>
-          <p:cNvSpPr/>
-          <p:nvPr/>
-        </p:nvSpPr>
-        <p:spPr>
-          <a:xfrm>
-            <a:off x="6995160" y="4389120"/>
-            <a:ext cx="2011680" cy="777240"/>
-          </a:xfrm>
-          <a:prstGeom prst="roundRect">
-            <a:avLst/>
-          </a:prstGeom>
-          <a:solidFill>
-            <a:srgbClr val="DBEAFE"/>
-          </a:solidFill>
-          <a:ln w="25400">
-            <a:solidFill>
-              <a:srgbClr val="1E40AF"/>
-            </a:solidFill>
-          </a:ln>
-        </p:spPr>
-        <p:style>
-          <a:lnRef idx="1">
-            <a:schemeClr val="accent1"/>
-          </a:lnRef>
-          <a:fillRef idx="3">
-            <a:schemeClr val="accent1"/>
-          </a:fillRef>
-          <a:effectRef idx="2">
-            <a:schemeClr val="accent1"/>
-          </a:effectRef>
-          <a:fontRef idx="minor">
-            <a:schemeClr val="lt1"/>
-          </a:fontRef>
-        </p:style>
-        <p:txBody>
-          <a:bodyPr rtlCol="0" anchor="ctr" wrap="square"/>
-          <a:lstStyle/>
-          <a:p>
-            <a:pPr algn="l"/>
-            <a:r>
-              <a:rPr sz="1000" b="1">
-                <a:solidFill>
-                  <a:srgbClr val="1F2937"/>
-                </a:solidFill>
-              </a:rPr>
-              <a:t>17. Liberar PDFs</a:t>
-            </a:r>
-          </a:p>
-          <a:p>
-            <a:pPr algn="l"/>
-            <a:r>
-              <a:rPr sz="700">
-                <a:solidFill>
-                  <a:srgbClr val="6B7280"/>
-                </a:solidFill>
-              </a:rPr>
-              <a:t>Todos os documentos
-liberados para download</a:t>
-            </a:r>
-          </a:p>
-        </p:txBody>
-      </p:sp>
-      <p:sp>
-        <p:nvSpPr>
-          <p:cNvPr id="35" name="Rounded Rectangle 34"/>
-          <p:cNvSpPr/>
-          <p:nvPr/>
-        </p:nvSpPr>
-        <p:spPr>
-          <a:xfrm>
-            <a:off x="4754880" y="4389120"/>
-            <a:ext cx="2011680" cy="777240"/>
-          </a:xfrm>
-          <a:prstGeom prst="roundRect">
-            <a:avLst/>
-          </a:prstGeom>
-          <a:solidFill>
-            <a:srgbClr val="DCFCE7"/>
-          </a:solidFill>
-          <a:ln w="25400">
-            <a:solidFill>
-              <a:srgbClr val="16A34A"/>
-            </a:solidFill>
-          </a:ln>
-        </p:spPr>
-        <p:style>
-          <a:lnRef idx="1">
-            <a:schemeClr val="accent1"/>
-          </a:lnRef>
-          <a:fillRef idx="3">
-            <a:schemeClr val="accent1"/>
-          </a:fillRef>
-          <a:effectRef idx="2">
-            <a:schemeClr val="accent1"/>
-          </a:effectRef>
-          <a:fontRef idx="minor">
-            <a:schemeClr val="lt1"/>
-          </a:fontRef>
-        </p:style>
-        <p:txBody>
-          <a:bodyPr rtlCol="0" anchor="ctr" wrap="square"/>
-          <a:lstStyle/>
-          <a:p>
-            <a:pPr algn="l"/>
-            <a:r>
-              <a:rPr sz="1000" b="1">
-                <a:solidFill>
-                  <a:srgbClr val="1F2937"/>
-                </a:solidFill>
-              </a:rPr>
-              <a:t>16. Aprovar + Pagar</a:t>
-            </a:r>
-          </a:p>
-          <a:p>
-            <a:pPr algn="l"/>
-            <a:r>
-              <a:rPr sz="700">
-                <a:solidFill>
-                  <a:srgbClr val="6B7280"/>
-                </a:solidFill>
-              </a:rPr>
-              <a:t>Empresa aprova proposta
-final e paga parcelas</a:t>
-            </a:r>
-          </a:p>
-        </p:txBody>
-      </p:sp>
-      <p:sp>
-        <p:nvSpPr>
-          <p:cNvPr id="36" name="Rounded Rectangle 35"/>
-          <p:cNvSpPr/>
-          <p:nvPr/>
-        </p:nvSpPr>
-        <p:spPr>
-          <a:xfrm>
-            <a:off x="274320" y="5349240"/>
-            <a:ext cx="11640312" cy="731520"/>
-          </a:xfrm>
-          <a:prstGeom prst="roundRect">
-            <a:avLst/>
-          </a:prstGeom>
-          <a:solidFill>
-            <a:srgbClr val="F3F4F6"/>
-          </a:solidFill>
-          <a:ln w="12700">
-            <a:solidFill>
-              <a:srgbClr val="6B7280"/>
-            </a:solidFill>
-          </a:ln>
-        </p:spPr>
-        <p:style>
-          <a:lnRef idx="1">
-            <a:schemeClr val="accent1"/>
-          </a:lnRef>
-          <a:fillRef idx="3">
-            <a:schemeClr val="accent1"/>
-          </a:fillRef>
-          <a:effectRef idx="2">
-            <a:schemeClr val="accent1"/>
-          </a:effectRef>
-          <a:fontRef idx="minor">
-            <a:schemeClr val="lt1"/>
-          </a:fontRef>
-        </p:style>
-        <p:txBody>
-          <a:bodyPr rtlCol="0" anchor="ctr" wrap="square"/>
-          <a:lstStyle/>
-          <a:p>
-            <a:pPr algn="ctr"/>
-            <a:r>
-              <a:rPr sz="1200" b="1">
-                <a:solidFill>
-                  <a:srgbClr val="1F2937"/>
-                </a:solidFill>
-              </a:rPr>
-              <a:t>Documentos Entregues (7 PDFs)</a:t>
-            </a:r>
-          </a:p>
-          <a:p>
-            <a:pPr algn="ctr"/>
-            <a:r>
-              <a:rPr sz="900">
-                <a:solidFill>
-                  <a:srgbClr val="6B7280"/>
-                </a:solidFill>
-              </a:rPr>
-              <a:t>Proposta Comercial | Relatorio COPSOQ-II | Inventario de Riscos | Plano de Acao | Programa de Treinamento | Checklist de Conformidade | Certificado NR-01</a:t>
-            </a:r>
-          </a:p>
-        </p:txBody>
-      </p:sp>
-      <p:sp>
-        <p:nvSpPr>
-          <p:cNvPr id="37" name="Rounded Rectangle 36"/>
-          <p:cNvSpPr/>
-          <p:nvPr/>
-        </p:nvSpPr>
-        <p:spPr>
-          <a:xfrm>
-            <a:off x="274320" y="6217920"/>
-            <a:ext cx="11640312" cy="411480"/>
-          </a:xfrm>
-          <a:prstGeom prst="roundRect">
-            <a:avLst/>
-          </a:prstGeom>
-          <a:solidFill>
-            <a:srgbClr val="FFFFFF"/>
+            <a:srgbClr val="E74C3C"/>
           </a:solidFill>
           <a:ln>
             <a:noFill/>
@@ -5073,71 +4610,208 @@
           </a:fontRef>
         </p:style>
         <p:txBody>
-          <a:bodyPr rtlCol="0" anchor="ctr"/>
-          <a:lstStyle/>
-          <a:p>
-            <a:pPr algn="ctr"/>
-            <a:r>
-              <a:rPr sz="900">
-                <a:solidFill>
-                  <a:srgbClr val="1E40AF"/>
-                </a:solidFill>
-              </a:rPr>
-              <a:t>  ● Consultoria  </a:t>
-            </a:r>
-            <a:r>
-              <a:rPr sz="900">
-                <a:solidFill>
-                  <a:srgbClr val="16A34A"/>
-                </a:solidFill>
-              </a:rPr>
-              <a:t>  ● Aprovacao/Envio  </a:t>
-            </a:r>
-            <a:r>
-              <a:rPr sz="900">
-                <a:solidFill>
-                  <a:srgbClr val="EA580C"/>
-                </a:solidFill>
-              </a:rPr>
-              <a:t>  ● Proposta  </a:t>
-            </a:r>
-            <a:r>
-              <a:rPr sz="900">
-                <a:solidFill>
-                  <a:srgbClr val="7C3AED"/>
-                </a:solidFill>
-              </a:rPr>
-              <a:t>  ● Empresa  </a:t>
-            </a:r>
-            <a:r>
-              <a:rPr sz="900">
-                <a:solidFill>
-                  <a:srgbClr val="DC2626"/>
-                </a:solidFill>
-              </a:rPr>
-              <a:t>  ● COPSOQ-II  </a:t>
-            </a:r>
-            <a:r>
-              <a:rPr sz="900">
-                <a:solidFill>
-                  <a:srgbClr val="D97706"/>
-                </a:solidFill>
-              </a:rPr>
-              <a:t>  ● Analise NR-01  </a:t>
-            </a:r>
-          </a:p>
-        </p:txBody>
-      </p:sp>
-      <p:sp>
-        <p:nvSpPr>
-          <p:cNvPr id="38" name="TextBox 37"/>
+          <a:bodyPr rtlCol="0" anchor="ctr" wrap="square"/>
+          <a:lstStyle/>
+          <a:p>
+            <a:pPr algn="l">
+              <a:defRPr sz="1000" b="1">
+                <a:solidFill>
+                  <a:srgbClr val="FFFFFF"/>
+                </a:solidFill>
+              </a:defRPr>
+            </a:pPr>
+            <a:r>
+              <a:t>17</a:t>
+            </a:r>
+          </a:p>
+          <a:p>
+            <a:pPr algn="ctr">
+              <a:defRPr sz="1100" b="1">
+                <a:solidFill>
+                  <a:srgbClr val="FFFFFF"/>
+                </a:solidFill>
+              </a:defRPr>
+            </a:pPr>
+            <a:r>
+              <a:t>Aprovar + Pagar</a:t>
+            </a:r>
+          </a:p>
+          <a:p>
+            <a:pPr algn="ctr">
+              <a:defRPr sz="800">
+                <a:solidFill>
+                  <a:srgbClr val="FFFFFF"/>
+                </a:solidFill>
+              </a:defRPr>
+            </a:pPr>
+            <a:r>
+              <a:t>Aprovacao + parcelas</a:t>
+            </a:r>
+          </a:p>
+          <a:p>
+            <a:pPr algn="ctr">
+              <a:defRPr sz="800">
+                <a:solidFill>
+                  <a:srgbClr val="FFFFFF"/>
+                </a:solidFill>
+              </a:defRPr>
+            </a:pPr>
+            <a:r>
+              <a:t>40/30/30</a:t>
+            </a:r>
+          </a:p>
+        </p:txBody>
+      </p:sp>
+      <p:sp>
+        <p:nvSpPr>
+          <p:cNvPr id="21" name="Rounded Rectangle 20"/>
+          <p:cNvSpPr/>
+          <p:nvPr/>
+        </p:nvSpPr>
+        <p:spPr>
+          <a:xfrm>
+            <a:off x="9646920" y="4206240"/>
+            <a:ext cx="1691640" cy="1280160"/>
+          </a:xfrm>
+          <a:prstGeom prst="roundRect">
+            <a:avLst/>
+          </a:prstGeom>
+          <a:solidFill>
+            <a:srgbClr val="27AE60"/>
+          </a:solidFill>
+          <a:ln>
+            <a:noFill/>
+          </a:ln>
+        </p:spPr>
+        <p:style>
+          <a:lnRef idx="1">
+            <a:schemeClr val="accent1"/>
+          </a:lnRef>
+          <a:fillRef idx="3">
+            <a:schemeClr val="accent1"/>
+          </a:fillRef>
+          <a:effectRef idx="2">
+            <a:schemeClr val="accent1"/>
+          </a:effectRef>
+          <a:fontRef idx="minor">
+            <a:schemeClr val="lt1"/>
+          </a:fontRef>
+        </p:style>
+        <p:txBody>
+          <a:bodyPr rtlCol="0" anchor="ctr" wrap="square"/>
+          <a:lstStyle/>
+          <a:p>
+            <a:pPr algn="l">
+              <a:defRPr sz="1000" b="1">
+                <a:solidFill>
+                  <a:srgbClr val="FFFFFF"/>
+                </a:solidFill>
+              </a:defRPr>
+            </a:pPr>
+            <a:r>
+              <a:t>18</a:t>
+            </a:r>
+          </a:p>
+          <a:p>
+            <a:pPr algn="ctr">
+              <a:defRPr sz="1100" b="1">
+                <a:solidFill>
+                  <a:srgbClr val="FFFFFF"/>
+                </a:solidFill>
+              </a:defRPr>
+            </a:pPr>
+            <a:r>
+              <a:t>Liberar PDFs</a:t>
+            </a:r>
+          </a:p>
+          <a:p>
+            <a:pPr algn="ctr">
+              <a:defRPr sz="800">
+                <a:solidFill>
+                  <a:srgbClr val="FFFFFF"/>
+                </a:solidFill>
+              </a:defRPr>
+            </a:pPr>
+            <a:r>
+              <a:t>Docs liberados apos</a:t>
+            </a:r>
+          </a:p>
+          <a:p>
+            <a:pPr algn="ctr">
+              <a:defRPr sz="800">
+                <a:solidFill>
+                  <a:srgbClr val="FFFFFF"/>
+                </a:solidFill>
+              </a:defRPr>
+            </a:pPr>
+            <a:r>
+              <a:t>pagamento 100%</a:t>
+            </a:r>
+          </a:p>
+        </p:txBody>
+      </p:sp>
+      <p:sp>
+        <p:nvSpPr>
+          <p:cNvPr id="22" name="Rounded Rectangle 21"/>
+          <p:cNvSpPr/>
+          <p:nvPr/>
+        </p:nvSpPr>
+        <p:spPr>
+          <a:xfrm>
+            <a:off x="274320" y="5669280"/>
+            <a:ext cx="11612880" cy="457200"/>
+          </a:xfrm>
+          <a:prstGeom prst="roundRect">
+            <a:avLst/>
+          </a:prstGeom>
+          <a:solidFill>
+            <a:srgbClr val="27AE60"/>
+          </a:solidFill>
+          <a:ln>
+            <a:noFill/>
+          </a:ln>
+        </p:spPr>
+        <p:style>
+          <a:lnRef idx="1">
+            <a:schemeClr val="accent1"/>
+          </a:lnRef>
+          <a:fillRef idx="3">
+            <a:schemeClr val="accent1"/>
+          </a:fillRef>
+          <a:effectRef idx="2">
+            <a:schemeClr val="accent1"/>
+          </a:effectRef>
+          <a:fontRef idx="minor">
+            <a:schemeClr val="lt1"/>
+          </a:fontRef>
+        </p:style>
+        <p:txBody>
+          <a:bodyPr rtlCol="0" anchor="ctr" wrap="square"/>
+          <a:lstStyle/>
+          <a:p>
+            <a:pPr algn="ctr">
+              <a:defRPr sz="1000" b="1">
+                <a:solidFill>
+                  <a:srgbClr val="FFFFFF"/>
+                </a:solidFill>
+              </a:defRPr>
+            </a:pPr>
+            <a:r>
+              <a:t>Documentos Entregues (7 PDFs): Proposta Comercial | Relatorio COPSOQ-II | Inventario de Riscos | Plano de Acao | Programa de Treinamento | Checklist de Conformidade | Certificado NR-01</a:t>
+            </a:r>
+          </a:p>
+        </p:txBody>
+      </p:sp>
+      <p:sp>
+        <p:nvSpPr>
+          <p:cNvPr id="23" name="TextBox 22"/>
           <p:cNvSpPr txBox="1"/>
           <p:nvPr/>
         </p:nvSpPr>
         <p:spPr>
           <a:xfrm>
-            <a:off x="274320" y="6492240"/>
-            <a:ext cx="11640312" cy="274320"/>
+            <a:off x="274320" y="6263640"/>
+            <a:ext cx="11612880" cy="365760"/>
           </a:xfrm>
           <a:prstGeom prst="rect">
             <a:avLst/>
@@ -5150,13 +4824,14 @@
           </a:bodyPr>
           <a:lstStyle/>
           <a:p>
-            <a:pPr algn="ctr"/>
-            <a:r>
-              <a:rPr sz="800">
-                <a:solidFill>
-                  <a:srgbClr val="6B7280"/>
-                </a:solidFill>
-              </a:rPr>
+            <a:pPr algn="ctr">
+              <a:defRPr sz="900">
+                <a:solidFill>
+                  <a:srgbClr val="666666"/>
+                </a:solidFill>
+              </a:defRPr>
+            </a:pPr>
+            <a:r>
               <a:t>Black Belt Consultoria SST | contato@blackbeltconsultoria.com | blackbeltconsultoria.com</a:t>
             </a:r>
           </a:p>

</xml_diff>

<commit_message>
fix: SamurAI — corrige fluxo completo NR-01 (treinamento → checklist → proposta final)
- Bug 1: saveFinalProposal inseria com status='sent' antes de enviar email
  → corrigido para status='draft'; send_final_proposal_email já atualiza para pending_approval
- Bug 2: handler create_training gerava proposta final prematuramente, pulando o checklist
  → removido bloco saveFinalProposal do create_training; proposta final agora gerada
  somente após complete_checklist (fluxo correto: treinamento → checklist → proposta final)
- Padronizado headcount fallback para || 4 em complete_checklist e generate_final_proposal
- Fluxograma PPTX atualizado: 18 → 20 etapas (add Treinamento, Checklist+Cert, credenciais)

Co-Authored-By: Claude Sonnet 4.6 <noreply@anthropic.com>
</commit_message>
<xml_diff>
--- a/docs/Fluxograma_SamurAI_BlackBelt.pptx
+++ b/docs/Fluxograma_SamurAI_BlackBelt.pptx
@@ -7,7 +7,7 @@
   <p:sldIdLst>
     <p:sldId id="256" r:id="rId7"/>
   </p:sldIdLst>
-  <p:sldSz cx="12188952" cy="6858000" type="screen4x3"/>
+  <p:sldSz cx="12188952" cy="8778240" type="screen4x3"/>
   <p:notesSz cx="6858000" cy="9144000"/>
   <p:defaultTextStyle>
     <a:defPPr>
@@ -3868,6 +3868,18 @@
               <a:t>+ credenciais</a:t>
             </a:r>
           </a:p>
+          <a:p>
+            <a:pPr algn="ctr">
+              <a:defRPr sz="700">
+                <a:solidFill>
+                  <a:srgbClr val="FFFF99"/>
+                </a:solidFill>
+              </a:defRPr>
+            </a:pPr>
+            <a:r>
+              <a:t>✉ envia login e senha</a:t>
+            </a:r>
+          </a:p>
         </p:txBody>
       </p:sp>
       <p:sp>
@@ -4494,7 +4506,7 @@
         </p:nvSpPr>
         <p:spPr>
           <a:xfrm>
-            <a:off x="5897880" y="4206240"/>
+            <a:off x="9646920" y="5852160"/>
             <a:ext cx="1691640" cy="1280160"/>
           </a:xfrm>
           <a:prstGeom prst="roundRect">
@@ -4533,7 +4545,7 @@
               </a:defRPr>
             </a:pPr>
             <a:r>
-              <a:t>16</a:t>
+              <a:t>18</a:t>
             </a:r>
           </a:p>
           <a:p>
@@ -4582,7 +4594,7 @@
         </p:nvSpPr>
         <p:spPr>
           <a:xfrm>
-            <a:off x="7772400" y="4206240"/>
+            <a:off x="7772400" y="5852160"/>
             <a:ext cx="1691640" cy="1280160"/>
           </a:xfrm>
           <a:prstGeom prst="roundRect">
@@ -4621,7 +4633,7 @@
               </a:defRPr>
             </a:pPr>
             <a:r>
-              <a:t>17</a:t>
+              <a:t>19</a:t>
             </a:r>
           </a:p>
           <a:p>
@@ -4670,7 +4682,7 @@
         </p:nvSpPr>
         <p:spPr>
           <a:xfrm>
-            <a:off x="9646920" y="4206240"/>
+            <a:off x="5897880" y="5852160"/>
             <a:ext cx="1691640" cy="1280160"/>
           </a:xfrm>
           <a:prstGeom prst="roundRect">
@@ -4709,7 +4721,7 @@
               </a:defRPr>
             </a:pPr>
             <a:r>
-              <a:t>18</a:t>
+              <a:t>20</a:t>
             </a:r>
           </a:p>
           <a:p>
@@ -4746,6 +4758,182 @@
             </a:pPr>
             <a:r>
               <a:t>pagamento 100%</a:t>
+            </a:r>
+          </a:p>
+        </p:txBody>
+      </p:sp>
+      <p:sp>
+        <p:nvSpPr>
+          <p:cNvPr id="30" name="Rounded Rectangle 29"/>
+          <p:cNvSpPr/>
+          <p:nvPr/>
+        </p:nvSpPr>
+        <p:spPr>
+          <a:xfrm>
+            <a:off x="5897880" y="4206240"/>
+            <a:ext cx="1691640" cy="1280160"/>
+          </a:xfrm>
+          <a:prstGeom prst="roundRect">
+            <a:avLst/>
+          </a:prstGeom>
+          <a:solidFill>
+            <a:srgbClr val="1ABC9C"/>
+          </a:solidFill>
+          <a:ln>
+            <a:noFill/>
+          </a:ln>
+        </p:spPr>
+        <p:style>
+          <a:lnRef idx="1">
+            <a:schemeClr val="accent1"/>
+          </a:lnRef>
+          <a:fillRef idx="3">
+            <a:schemeClr val="accent1"/>
+          </a:fillRef>
+          <a:effectRef idx="2">
+            <a:schemeClr val="accent1"/>
+          </a:effectRef>
+          <a:fontRef idx="minor">
+            <a:schemeClr val="lt1"/>
+          </a:fontRef>
+        </p:style>
+        <p:txBody>
+          <a:bodyPr rtlCol="0" anchor="ctr" wrap="square"/>
+          <a:lstStyle/>
+          <a:p>
+            <a:pPr algn="l">
+              <a:defRPr sz="1000" b="1">
+                <a:solidFill>
+                  <a:srgbClr val="FFFFFF"/>
+                </a:solidFill>
+              </a:defRPr>
+            </a:pPr>
+            <a:r>
+              <a:t>16</a:t>
+            </a:r>
+          </a:p>
+          <a:p>
+            <a:pPr algn="ctr">
+              <a:defRPr sz="1100" b="1">
+                <a:solidFill>
+                  <a:srgbClr val="FFFFFF"/>
+                </a:solidFill>
+              </a:defRPr>
+            </a:pPr>
+            <a:r>
+              <a:t>Programa Treinamento</a:t>
+            </a:r>
+          </a:p>
+          <a:p>
+            <a:pPr algn="ctr">
+              <a:defRPr sz="800">
+                <a:solidFill>
+                  <a:srgbClr val="FFFFFF"/>
+                </a:solidFill>
+              </a:defRPr>
+            </a:pPr>
+            <a:r>
+              <a:t>8h, 6 modulos</a:t>
+            </a:r>
+          </a:p>
+          <a:p>
+            <a:pPr algn="ctr">
+              <a:defRPr sz="800">
+                <a:solidFill>
+                  <a:srgbClr val="FFFFFF"/>
+                </a:solidFill>
+              </a:defRPr>
+            </a:pPr>
+            <a:r>
+              <a:t>(novo)</a:t>
+            </a:r>
+          </a:p>
+        </p:txBody>
+      </p:sp>
+      <p:sp>
+        <p:nvSpPr>
+          <p:cNvPr id="31" name="Rounded Rectangle 30"/>
+          <p:cNvSpPr/>
+          <p:nvPr/>
+        </p:nvSpPr>
+        <p:spPr>
+          <a:xfrm>
+            <a:off x="7772400" y="4206240"/>
+            <a:ext cx="1691640" cy="1280160"/>
+          </a:xfrm>
+          <a:prstGeom prst="roundRect">
+            <a:avLst/>
+          </a:prstGeom>
+          <a:solidFill>
+            <a:srgbClr val="9B59B6"/>
+          </a:solidFill>
+          <a:ln>
+            <a:noFill/>
+          </a:ln>
+        </p:spPr>
+        <p:style>
+          <a:lnRef idx="1">
+            <a:schemeClr val="accent1"/>
+          </a:lnRef>
+          <a:fillRef idx="3">
+            <a:schemeClr val="accent1"/>
+          </a:fillRef>
+          <a:effectRef idx="2">
+            <a:schemeClr val="accent1"/>
+          </a:effectRef>
+          <a:fontRef idx="minor">
+            <a:schemeClr val="lt1"/>
+          </a:fontRef>
+        </p:style>
+        <p:txBody>
+          <a:bodyPr rtlCol="0" anchor="ctr" wrap="square"/>
+          <a:lstStyle/>
+          <a:p>
+            <a:pPr algn="l">
+              <a:defRPr sz="1000" b="1">
+                <a:solidFill>
+                  <a:srgbClr val="FFFFFF"/>
+                </a:solidFill>
+              </a:defRPr>
+            </a:pPr>
+            <a:r>
+              <a:t>17</a:t>
+            </a:r>
+          </a:p>
+          <a:p>
+            <a:pPr algn="ctr">
+              <a:defRPr sz="1100" b="1">
+                <a:solidFill>
+                  <a:srgbClr val="FFFFFF"/>
+                </a:solidFill>
+              </a:defRPr>
+            </a:pPr>
+            <a:r>
+              <a:t>Checklist + Cert.</a:t>
+            </a:r>
+          </a:p>
+          <a:p>
+            <a:pPr algn="ctr">
+              <a:defRPr sz="800">
+                <a:solidFill>
+                  <a:srgbClr val="FFFFFF"/>
+                </a:solidFill>
+              </a:defRPr>
+            </a:pPr>
+            <a:r>
+              <a:t>NR-01</a:t>
+            </a:r>
+          </a:p>
+          <a:p>
+            <a:pPr algn="ctr">
+              <a:defRPr sz="800">
+                <a:solidFill>
+                  <a:srgbClr val="FFFFFF"/>
+                </a:solidFill>
+              </a:defRPr>
+            </a:pPr>
+            <a:r>
+              <a:t>Emissao automatica</a:t>
             </a:r>
           </a:p>
         </p:txBody>
@@ -4758,7 +4946,7 @@
         </p:nvSpPr>
         <p:spPr>
           <a:xfrm>
-            <a:off x="274320" y="5669280"/>
+            <a:off x="274320" y="7498080"/>
             <a:ext cx="11612880" cy="457200"/>
           </a:xfrm>
           <a:prstGeom prst="roundRect">
@@ -4810,7 +4998,7 @@
         </p:nvSpPr>
         <p:spPr>
           <a:xfrm>
-            <a:off x="274320" y="6263640"/>
+            <a:off x="274320" y="8138160"/>
             <a:ext cx="11612880" cy="365760"/>
           </a:xfrm>
           <a:prstGeom prst="rect">

</xml_diff>